<commit_message>
Update BloodLink presentation with the latest version
</commit_message>
<xml_diff>
--- a/docs/BloodLink-presentation.pptx
+++ b/docs/BloodLink-presentation.pptx
@@ -4,6 +4,9 @@
   <p:sldMasterIdLst>
     <p:sldMasterId id="2147483648" r:id="rId1"/>
   </p:sldMasterIdLst>
+  <p:notesMasterIdLst>
+    <p:notesMasterId r:id="rId12"/>
+  </p:notesMasterIdLst>
   <p:sldIdLst>
     <p:sldId id="256" r:id="rId2"/>
     <p:sldId id="257" r:id="rId3"/>
@@ -16,10 +19,7 @@
     <p:sldId id="264" r:id="rId10"/>
     <p:sldId id="265" r:id="rId11"/>
   </p:sldIdLst>
-  <p:notesMasterIdLst>
-    <p:notesMasterId r:id="rId12"/>
-  </p:notesMasterIdLst>
-  <p:sldSz cx="9144000" cy="5143500"/>
+  <p:sldSz cx="9144000" cy="5143500" type="screen16x9"/>
   <p:notesSz cx="5143500" cy="9144000"/>
   <p:defaultTextStyle>
     <a:lvl1pPr marL="0" algn="l" defTabSz="914400" rtl="0" eaLnBrk="1" latinLnBrk="0" hangingPunct="1">
@@ -116,40 +116,40 @@
   <p:extLst>
     <p:ext uri="{521415D9-36F7-43E2-AB2F-B90AF26B5E84}">
       <p14:sectionLst xmlns:p14="http://schemas.microsoft.com/office/powerpoint/2010/main">
-        <p14:section name="Introduction" id="{73f03422-862a-b5fa-1acd-0611df344be8}">
+        <p14:section name="Introduction" id="{73F03422-862A-B5FA-1ACD-0611DF344BE8}">
           <p14:sldIdLst>
             <p14:sldId id="256"/>
           </p14:sldIdLst>
         </p14:section>
-        <p14:section name="Application" id="{9457986b-d101-4d0e-2507-49560667b44d}">
+        <p14:section name="Application" id="{9457986B-D101-4D0E-2507-49560667B44D}">
           <p14:sldIdLst>
             <p14:sldId id="257"/>
           </p14:sldIdLst>
         </p14:section>
-        <p14:section name="Delivery" id="{f45b8b09-15ce-91d3-a671-0bf08b6b26b1}">
+        <p14:section name="Delivery" id="{F45B8B09-15CE-91D3-A671-0BF08B6B26B1}">
           <p14:sldIdLst>
             <p14:sldId id="258"/>
             <p14:sldId id="259"/>
           </p14:sldIdLst>
         </p14:section>
-        <p14:section name="Security" id="{4bb47bec-87db-5382-52ab-797ad0d5c514}">
+        <p14:section name="Security" id="{4BB47BEC-87DB-5382-52AB-797AD0D5C514}">
           <p14:sldIdLst>
             <p14:sldId id="260"/>
           </p14:sldIdLst>
         </p14:section>
-        <p14:section name="Infrastructure" id="{9359ab50-defe-54e9-272b-ae32c94759ea}">
+        <p14:section name="Infrastructure" id="{9359AB50-DEFE-54E9-272B-AE32C94759EA}">
           <p14:sldIdLst>
             <p14:sldId id="261"/>
             <p14:sldId id="262"/>
           </p14:sldIdLst>
         </p14:section>
-        <p14:section name="Operations" id="{dde544a8-2085-6088-b89c-1a12e30745d6}">
+        <p14:section name="Operations" id="{DDE544A8-2085-6088-B89C-1A12E30745D6}">
           <p14:sldIdLst>
             <p14:sldId id="263"/>
             <p14:sldId id="264"/>
           </p14:sldIdLst>
         </p14:section>
-        <p14:section name="Conclusion" id="{0b39ed0e-430f-fc34-7437-09253d55b4eb}">
+        <p14:section name="Conclusion" id="{0B39ED0E-430F-FC34-7437-09253D55B4EB}">
           <p14:sldIdLst>
             <p14:sldId id="265"/>
           </p14:sldIdLst>
@@ -161,6 +161,43 @@
     </p:ext>
   </p:extLst>
 </p:presentation>
+</file>
+
+<file path=ppt/changesInfos/changesInfo1.xml><?xml version="1.0" encoding="utf-8"?>
+<pc:chgInfo xmlns:a="http://schemas.openxmlformats.org/drawingml/2006/main" xmlns:r="http://schemas.openxmlformats.org/officeDocument/2006/relationships" xmlns:ac="http://schemas.microsoft.com/office/drawing/2013/main/command" xmlns:pc="http://schemas.microsoft.com/office/powerpoint/2013/main/command">
+  <pc:docChgLst>
+    <pc:chgData name="Ishan Ganguly" userId="fb76b3add9a405f3" providerId="LiveId" clId="{EA2BF668-E36C-499F-A425-E8519F6EE2C5}"/>
+    <pc:docChg chg="custSel modSld">
+      <pc:chgData name="Ishan Ganguly" userId="fb76b3add9a405f3" providerId="LiveId" clId="{EA2BF668-E36C-499F-A425-E8519F6EE2C5}" dt="2026-10-16T14:10:11.455" v="5" actId="478"/>
+      <pc:docMkLst>
+        <pc:docMk/>
+      </pc:docMkLst>
+      <pc:sldChg chg="delSp modSp mod">
+        <pc:chgData name="Ishan Ganguly" userId="fb76b3add9a405f3" providerId="LiveId" clId="{EA2BF668-E36C-499F-A425-E8519F6EE2C5}" dt="2026-10-16T14:10:11.455" v="5" actId="478"/>
+        <pc:sldMkLst>
+          <pc:docMk/>
+          <pc:sldMk cId="0" sldId="265"/>
+        </pc:sldMkLst>
+        <pc:spChg chg="del mod">
+          <ac:chgData name="Ishan Ganguly" userId="fb76b3add9a405f3" providerId="LiveId" clId="{EA2BF668-E36C-499F-A425-E8519F6EE2C5}" dt="2026-10-16T14:10:06.255" v="3" actId="478"/>
+          <ac:spMkLst>
+            <pc:docMk/>
+            <pc:sldMk cId="0" sldId="265"/>
+            <ac:spMk id="13" creationId="{00000000-0000-0000-0000-000000000000}"/>
+          </ac:spMkLst>
+        </pc:spChg>
+        <pc:spChg chg="del mod">
+          <ac:chgData name="Ishan Ganguly" userId="fb76b3add9a405f3" providerId="LiveId" clId="{EA2BF668-E36C-499F-A425-E8519F6EE2C5}" dt="2026-10-16T14:10:11.455" v="5" actId="478"/>
+          <ac:spMkLst>
+            <pc:docMk/>
+            <pc:sldMk cId="0" sldId="265"/>
+            <ac:spMk id="14" creationId="{00000000-0000-0000-0000-000000000000}"/>
+          </ac:spMkLst>
+        </pc:spChg>
+      </pc:sldChg>
+    </pc:docChg>
+  </pc:docChgLst>
+</pc:chgInfo>
 </file>
 
 <file path=ppt/notesMasters/notesMaster1.xml><?xml version="1.0" encoding="utf-8"?>
@@ -185,234 +222,10 @@
           <a:chExt cx="0" cy="0"/>
         </a:xfrm>
       </p:grpSpPr>
-      <p:sp>
-        <p:nvSpPr>
-          <p:cNvPr id="2" name="Header Placeholder 1"/>
-          <p:cNvSpPr>
-            <a:spLocks noGrp="1"/>
-          </p:cNvSpPr>
-          <p:nvPr>
-            <p:ph type="hdr" sz="quarter"/>
-          </p:nvPr>
-        </p:nvSpPr>
-        <p:spPr>
-          <a:xfrm>
-            <a:off x="0" y="0"/>
-            <a:ext cx="2971800" cy="458788"/>
-          </a:xfrm>
-          <a:prstGeom prst="rect">
-            <a:avLst/>
-          </a:prstGeom>
-        </p:spPr>
-        <p:txBody>
-          <a:bodyPr vert="horz" lIns="91440" tIns="45720" rIns="91440" bIns="45720" rtlCol="0"/>
-          <a:lstStyle>
-            <a:lvl1pPr algn="l">
-              <a:defRPr sz="1200"/>
-            </a:lvl1pPr>
-          </a:lstStyle>
-          <a:p>
-            <a:endParaRPr lang="en-US"/>
-          </a:p>
-        </p:txBody>
-      </p:sp>
-      <p:sp>
-        <p:nvSpPr>
-          <p:cNvPr id="3" name="Date Placeholder 2"/>
-          <p:cNvSpPr>
-            <a:spLocks noGrp="1"/>
-          </p:cNvSpPr>
-          <p:nvPr>
-            <p:ph type="dt" idx="1"/>
-          </p:nvPr>
-        </p:nvSpPr>
-        <p:spPr>
-          <a:xfrm>
-            <a:off x="3884613" y="0"/>
-            <a:ext cx="2971800" cy="458788"/>
-          </a:xfrm>
-          <a:prstGeom prst="rect">
-            <a:avLst/>
-          </a:prstGeom>
-        </p:spPr>
-        <p:txBody>
-          <a:bodyPr vert="horz" lIns="91440" tIns="45720" rIns="91440" bIns="45720" rtlCol="0"/>
-          <a:lstStyle>
-            <a:lvl1pPr algn="r">
-              <a:defRPr sz="1200"/>
-            </a:lvl1pPr>
-          </a:lstStyle>
-          <a:p>
-            <a:fld id="{5282F153-3F37-0F45-9E97-73ACFA13230C}" type="datetimeFigureOut">
-              <a:rPr lang="en-US"/>
-              <a:t>7/23/19</a:t>
-            </a:fld>
-            <a:endParaRPr lang="en-US"/>
-          </a:p>
-        </p:txBody>
-      </p:sp>
-      <p:sp>
-        <p:nvSpPr>
-          <p:cNvPr id="4" name="Slide Image Placeholder 3"/>
-          <p:cNvSpPr>
-            <a:spLocks noGrp="1" noRot="1" noChangeAspect="1"/>
-          </p:cNvSpPr>
-          <p:nvPr>
-            <p:ph type="sldImg" idx="2"/>
-          </p:nvPr>
-        </p:nvSpPr>
-        <p:spPr>
-          <a:xfrm>
-            <a:off x="685800" y="1143000"/>
-            <a:ext cx="5486400" cy="3086100"/>
-          </a:xfrm>
-          <a:prstGeom prst="rect">
-            <a:avLst/>
-          </a:prstGeom>
-          <a:noFill/>
-          <a:ln w="12700">
-            <a:solidFill>
-              <a:prstClr val="black"/>
-            </a:solidFill>
-          </a:ln>
-        </p:spPr>
-        <p:txBody>
-          <a:bodyPr vert="horz" lIns="91440" tIns="45720" rIns="91440" bIns="45720" rtlCol="0" anchor="ctr"/>
-          <a:lstStyle/>
-          <a:p>
-            <a:endParaRPr lang="en-US"/>
-          </a:p>
-        </p:txBody>
-      </p:sp>
-      <p:sp>
-        <p:nvSpPr>
-          <p:cNvPr id="5" name="Notes Placeholder 4"/>
-          <p:cNvSpPr>
-            <a:spLocks noGrp="1"/>
-          </p:cNvSpPr>
-          <p:nvPr>
-            <p:ph type="body" sz="quarter" idx="3"/>
-          </p:nvPr>
-        </p:nvSpPr>
-        <p:spPr>
-          <a:xfrm>
-            <a:off x="685800" y="4400550"/>
-            <a:ext cx="5486400" cy="3600450"/>
-          </a:xfrm>
-          <a:prstGeom prst="rect">
-            <a:avLst/>
-          </a:prstGeom>
-        </p:spPr>
-        <p:txBody>
-          <a:bodyPr vert="horz" lIns="91440" tIns="45720" rIns="91440" bIns="45720" rtlCol="0"/>
-          <a:lstStyle/>
-          <a:p>
-            <a:pPr lvl="0"/>
-            <a:r>
-              <a:rPr lang="en-US"/>
-              <a:t>Click to edit Master text styles</a:t>
-            </a:r>
-          </a:p>
-          <a:p>
-            <a:pPr lvl="1"/>
-            <a:r>
-              <a:rPr lang="en-US"/>
-              <a:t>Second level</a:t>
-            </a:r>
-          </a:p>
-          <a:p>
-            <a:pPr lvl="2"/>
-            <a:r>
-              <a:rPr lang="en-US"/>
-              <a:t>Third level</a:t>
-            </a:r>
-          </a:p>
-          <a:p>
-            <a:pPr lvl="3"/>
-            <a:r>
-              <a:rPr lang="en-US"/>
-              <a:t>Fourth level</a:t>
-            </a:r>
-          </a:p>
-          <a:p>
-            <a:pPr lvl="4"/>
-            <a:r>
-              <a:rPr lang="en-US"/>
-              <a:t>Fifth level</a:t>
-            </a:r>
-          </a:p>
-        </p:txBody>
-      </p:sp>
-      <p:sp>
-        <p:nvSpPr>
-          <p:cNvPr id="6" name="Footer Placeholder 5"/>
-          <p:cNvSpPr>
-            <a:spLocks noGrp="1"/>
-          </p:cNvSpPr>
-          <p:nvPr>
-            <p:ph type="ftr" sz="quarter" idx="4"/>
-          </p:nvPr>
-        </p:nvSpPr>
-        <p:spPr>
-          <a:xfrm>
-            <a:off x="0" y="8685213"/>
-            <a:ext cx="2971800" cy="458787"/>
-          </a:xfrm>
-          <a:prstGeom prst="rect">
-            <a:avLst/>
-          </a:prstGeom>
-        </p:spPr>
-        <p:txBody>
-          <a:bodyPr vert="horz" lIns="91440" tIns="45720" rIns="91440" bIns="45720" rtlCol="0" anchor="b"/>
-          <a:lstStyle>
-            <a:lvl1pPr algn="l">
-              <a:defRPr sz="1200"/>
-            </a:lvl1pPr>
-          </a:lstStyle>
-          <a:p>
-            <a:endParaRPr lang="en-US"/>
-          </a:p>
-        </p:txBody>
-      </p:sp>
-      <p:sp>
-        <p:nvSpPr>
-          <p:cNvPr id="7" name="Slide Number Placeholder 6"/>
-          <p:cNvSpPr>
-            <a:spLocks noGrp="1"/>
-          </p:cNvSpPr>
-          <p:nvPr>
-            <p:ph type="sldNum" sz="quarter" idx="5"/>
-          </p:nvPr>
-        </p:nvSpPr>
-        <p:spPr>
-          <a:xfrm>
-            <a:off x="3884613" y="8685213"/>
-            <a:ext cx="2971800" cy="458787"/>
-          </a:xfrm>
-          <a:prstGeom prst="rect">
-            <a:avLst/>
-          </a:prstGeom>
-        </p:spPr>
-        <p:txBody>
-          <a:bodyPr vert="horz" lIns="91440" tIns="45720" rIns="91440" bIns="45720" rtlCol="0" anchor="b"/>
-          <a:lstStyle>
-            <a:lvl1pPr algn="r">
-              <a:defRPr sz="1200"/>
-            </a:lvl1pPr>
-          </a:lstStyle>
-          <a:p>
-            <a:fld id="{CE5E9CC1-C706-0F49-92D6-E571CC5EEA8F}" type="slidenum">
-              <a:rPr lang="en-US"/>
-              <a:t>‹#›</a:t>
-            </a:fld>
-            <a:endParaRPr lang="en-US"/>
-          </a:p>
-        </p:txBody>
-      </p:sp>
     </p:spTree>
     <p:extLst>
       <p:ext uri="{BB962C8B-B14F-4D97-AF65-F5344CB8AC3E}">
-        <p14:creationId xmlns:p14="http://schemas.microsoft.com/office/powerpoint/2010/main" val="1024086991"/>
+        <p14:creationId xmlns:p14="http://schemas.microsoft.com/office/powerpoint/2010/main" val="2695409008"/>
       </p:ext>
     </p:extLst>
   </p:cSld>
@@ -560,7 +373,6 @@
               <a:rPr lang="en-US" dirty="0"/>
               <a:t>BloodLink manages a blood bank: donors, donated units, hospital requests, and which units can safely go to which patient. The point of the project is the delivery pipeline around it: every change is tested, scanned, built into an image tagged with its commit, and deployed to Kubernetes, locally on kind and on AWS EKS built with Terraform. O- is highlighted because it is the universal donor: the allocator keeps it for last.</a:t>
             </a:r>
-            <a:endParaRPr lang="en-US" dirty="0"/>
           </a:p>
         </p:txBody>
       </p:sp>
@@ -648,7 +460,6 @@
               <a:rPr lang="en-US" dirty="0"/>
               <a:t>These were real problems, not staged ones, and each is written up in the runbook. The pattern each time: read the exact error, find the source of truth, and fix it in code rather than by hand. The AWS account's organization policy only allows Sydney; a dry run per region proved it. The deploy role rejected GitHub because GitHub changed its token format; CloudTrail showed the exact subject. Grafana was killed for using more memory than its limit. And on my laptop's slow disk, etcd writes took over a second, so the scheduler kept losing leader election. Thank you, happy to take questions.</a:t>
             </a:r>
-            <a:endParaRPr lang="en-US" dirty="0"/>
           </a:p>
         </p:txBody>
       </p:sp>
@@ -736,7 +547,6 @@
               <a:rPr lang="en-US" dirty="0"/>
               <a:t>Three rules make this more than CRUD. Compatibility: an A- patient can only get A- or O-; the allocator prefers the exact group and keeps O- for patients who can receive nothing else. Expiry: red cells last 42 days, so the oldest compatible unit goes first to reduce wastage. Emergencies jump the queue. The dashboard shows stock per group with LOW and CRITICAL levels, units about to expire, fill rate and wastage.</a:t>
             </a:r>
-            <a:endParaRPr lang="en-US" dirty="0"/>
           </a:p>
         </p:txBody>
       </p:sp>
@@ -824,7 +634,6 @@
               <a:rPr lang="en-US" dirty="0"/>
               <a:t>The pipeline is one workflow file. Four jobs run in parallel: backend lint and tests with a 90% coverage floor, the frontend build, secret and dependency scanning, and Terraform and Helm validation with a Trivy misconfiguration scan. Only if all four pass are the images built. Trivy scans them before they are pushed, so a vulnerable image never reaches the registry. Images are tagged with the full commit SHA, so any pod can be traced to its commit. On main, the last job deploys to EKS: GitHub gets short-lived AWS credentials through OIDC, no access keys are stored anywhere.</a:t>
             </a:r>
-            <a:endParaRPr lang="en-US" dirty="0"/>
           </a:p>
         </p:txBody>
       </p:sp>
@@ -912,7 +721,6 @@
               <a:rPr lang="en-US" dirty="0"/>
               <a:t>This is the quality gate working on a realistic mistake. The change compiles and the app would run, but it breaks a medical rule. The compatibility test caught it, the pipeline graph shows the build and deploy jobs were skipped, so nothing reached a cluster. Tests run against a throwaway SQLite database, never the real one.</a:t>
             </a:r>
-            <a:endParaRPr lang="en-US" dirty="0"/>
           </a:p>
         </p:txBody>
       </p:sp>
@@ -1000,7 +808,6 @@
               <a:rPr lang="en-US" dirty="0"/>
               <a:t>Trivy scans every image before it is pushed. The first version of the gate ignored vulnerabilities without a fix, and the backend passed. Scanning without that exception showed 44 HIGH findings from 8 CVEs in Debian packages the app never uses, such as util-linux. CVE-2026-76642: mount does not check whether its helper failed before running privileged hooks, so a local user could escalate privileges. Our container runs as a non-root user with a read-only filesystem and never mounts anything, so the practical risk was low, but rather than accept it we moved to Alpine, which does not ship those packages, and made the gate strict. Other layers: gitleaks over the whole history, dependency audits, Pod Security restricted, and a NetworkPolicy so only the backend can reach the database.</a:t>
             </a:r>
-            <a:endParaRPr lang="en-US" dirty="0"/>
           </a:p>
         </p:txBody>
       </p:sp>
@@ -1088,7 +895,6 @@
               <a:rPr lang="en-US" dirty="0"/>
               <a:t>Terraform builds a VPC across two availability zones with public subnets for the load balancer and private subnets for the nodes, a NAT gateway, and an EKS 1.35 cluster with a managed node group and add-ons, including the EBS CSI driver and NetworkPolicy support. State is in S3. I never ran apply blind: plan to a file, review it, apply that file. The cluster ran for about an hour, the app served traffic through an AWS load balancer, and then destroy removed all 66 resources; I checked AWS directly that nothing was left. The region is Sydney because the AWS account's organization policy only allows that region; region is a variable, so nothing else changed.</a:t>
             </a:r>
-            <a:endParaRPr lang="en-US" dirty="0"/>
           </a:p>
         </p:txBody>
       </p:sp>
@@ -1176,7 +982,6 @@
               <a:rPr lang="en-US" dirty="0"/>
               <a:t>The chart deploys the backend and frontend with two replicas each, PostgreSQL as a StatefulSet on a persistent volume, ClusterIP services, and an Ingress that routes /api to the backend and / to the frontend. Under a load test the HorizontalPodAutoscaler scaled the backend from 2 to 6 pods. Each pod runs migrations in an init container; an advisory lock means two pods starting together never migrate at the same time. The namespace enforces Pod Security restricted, and a NetworkPolicy lets only database clients reach Postgres. I also practised six failures: bad image tag, a Service with no endpoints, database down, wrong password, out of memory, and a bad release with helm rollback.</a:t>
             </a:r>
-            <a:endParaRPr lang="en-US" dirty="0"/>
           </a:p>
         </p:txBody>
       </p:sp>
@@ -1264,7 +1069,6 @@
               <a:rPr lang="en-US" dirty="0"/>
               <a:t>Besides the usual request rate, errors and latency, the backend exports business metrics: available units per blood group, units expiring within seven days, and how long requests take to fill. Seven alert rules cover the service being down, error rate, latency, critical stock, low O- stock, units expiring soon, and emergency requests waiting. Critical stock is firing right now because A-, B- and AB- are below five units. The dashboard shows the load test spike and the HPA scaling out to six replicas.</a:t>
             </a:r>
-            <a:endParaRPr lang="en-US" dirty="0"/>
           </a:p>
         </p:txBody>
       </p:sp>
@@ -1352,7 +1156,6 @@
               <a:rPr lang="en-US" dirty="0"/>
               <a:t>Live: make a small visible change, push, open the Actions run and watch the jobs go green in about two minutes, then run helm upgrade with the new SHA and refresh the app: the footer shows the new build. On EKS this was fully automatic: the deploy job signed in to AWS with OIDC and upgraded the release itself. The first attempt failed because GitHub now sends an immutable subject in its token; CloudTrail showed the exact value and I fixed the trust policy in Terraform. If the network fails during the talk, the recording is in docs/demo.</a:t>
             </a:r>
-            <a:endParaRPr lang="en-US" dirty="0"/>
           </a:p>
         </p:txBody>
       </p:sp>
@@ -1430,6 +1233,7 @@
         <a:solidFill>
           <a:srgbClr val="1C1B22"/>
         </a:solidFill>
+        <a:effectLst/>
       </p:bgPr>
     </p:bg>
     <p:spTree>
@@ -1449,9 +1253,11 @@
       <p:sp>
         <p:nvSpPr>
           <p:cNvPr id="2" name="Text 0"/>
-          <p:cNvSpPr/>
+          <p:cNvSpPr>
+            <a:spLocks noGrp="1"/>
+          </p:cNvSpPr>
           <p:nvPr>
-            <p:ph idx="100" type="title" hasCustomPrompt="1"/>
+            <p:ph type="title" idx="100" hasCustomPrompt="1"/>
           </p:nvPr>
         </p:nvSpPr>
         <p:spPr>
@@ -1468,7 +1274,7 @@
         <p:txBody>
           <a:bodyPr wrap="square" rtlCol="0"/>
           <a:lstStyle>
-            <a:lvl1pPr algn="l" indent="0" marL="0">
+            <a:lvl1pPr marL="0" indent="0" algn="l">
               <a:buNone/>
               <a:defRPr lang="en-US" sz="4400" b="1" dirty="0">
                 <a:solidFill>
@@ -1481,7 +1287,7 @@
             </a:lvl1pPr>
           </a:lstStyle>
           <a:p>
-            <a:pPr algn="l" indent="0" marL="0">
+            <a:pPr marL="0" indent="0" algn="l">
               <a:buNone/>
             </a:pPr>
             <a:endParaRPr lang="en-US" sz="4400" dirty="0"/>
@@ -1491,9 +1297,11 @@
       <p:sp>
         <p:nvSpPr>
           <p:cNvPr id="3" name="Text 0"/>
-          <p:cNvSpPr/>
+          <p:cNvSpPr>
+            <a:spLocks noGrp="1"/>
+          </p:cNvSpPr>
           <p:nvPr>
-            <p:ph idx="101" type="body" hasCustomPrompt="1"/>
+            <p:ph type="body" idx="101" hasCustomPrompt="1"/>
           </p:nvPr>
         </p:nvSpPr>
         <p:spPr>
@@ -1510,7 +1318,7 @@
         <p:txBody>
           <a:bodyPr wrap="square" rtlCol="0"/>
           <a:lstStyle>
-            <a:lvl1pPr indent="0" marL="0">
+            <a:lvl1pPr marL="0" indent="0">
               <a:buNone/>
               <a:defRPr lang="en-US" sz="1800" dirty="0">
                 <a:solidFill>
@@ -1520,7 +1328,7 @@
             </a:lvl1pPr>
           </a:lstStyle>
           <a:p>
-            <a:pPr indent="0" marL="0">
+            <a:pPr marL="0" indent="0">
               <a:buNone/>
             </a:pPr>
             <a:endParaRPr lang="en-US" sz="1800" dirty="0"/>
@@ -1543,6 +1351,7 @@
         <a:solidFill>
           <a:srgbClr val="FFFFFF"/>
         </a:solidFill>
+        <a:effectLst/>
       </p:bgPr>
     </p:bg>
     <p:spTree>
@@ -1562,9 +1371,11 @@
       <p:sp>
         <p:nvSpPr>
           <p:cNvPr id="2" name="Text 0"/>
-          <p:cNvSpPr/>
+          <p:cNvSpPr>
+            <a:spLocks noGrp="1"/>
+          </p:cNvSpPr>
           <p:nvPr>
-            <p:ph idx="100" type="title" hasCustomPrompt="1"/>
+            <p:ph type="title" idx="100" hasCustomPrompt="1"/>
           </p:nvPr>
         </p:nvSpPr>
         <p:spPr>
@@ -1581,7 +1392,7 @@
         <p:txBody>
           <a:bodyPr wrap="square" rtlCol="0"/>
           <a:lstStyle>
-            <a:lvl1pPr algn="l" indent="0" marL="0">
+            <a:lvl1pPr marL="0" indent="0" algn="l">
               <a:buNone/>
               <a:defRPr lang="en-US" sz="3000" b="1" dirty="0">
                 <a:solidFill>
@@ -1594,7 +1405,7 @@
             </a:lvl1pPr>
           </a:lstStyle>
           <a:p>
-            <a:pPr algn="l" indent="0" marL="0">
+            <a:pPr marL="0" indent="0" algn="l">
               <a:buNone/>
             </a:pPr>
             <a:endParaRPr lang="en-US" sz="3000" dirty="0"/>
@@ -1622,7 +1433,7 @@
           <a:bodyPr wrap="square" lIns="0" tIns="0" rIns="0" bIns="0" rtlCol="0" anchor="ctr"/>
           <a:lstStyle/>
           <a:p>
-            <a:pPr indent="0" marL="0">
+            <a:pPr marL="0" indent="0">
               <a:buNone/>
             </a:pPr>
             <a:r>
@@ -1657,7 +1468,7 @@
           </a:prstGeom>
           <a:extLst>
             <a:ext uri="{C572A759-6A51-4108-AA02-DFA0A04FC94B}">
-              <ma14:wrappingTextBoxFlag xmlns:ma14="http://schemas.microsoft.com/office/mac/drawingml/2011/main" val="0"/>
+              <ma14:wrappingTextBoxFlag xmlns:ma14="http://schemas.microsoft.com/office/mac/drawingml/2011/main" xmlns="" val="0"/>
             </a:ext>
           </a:extLst>
         </p:spPr>
@@ -1675,8 +1486,8 @@
           <a:p>
             <a:pPr algn="r"/>
             <a:fld id="{F7021451-1387-4CA6-816F-3879F97B5CBC}" type="slidenum">
-              <a:rPr b="0" lang="en-US"/>
-              <a:t>1003</a:t>
+              <a:rPr lang="en-US" b="0"/>
+              <a:t>‹#›</a:t>
             </a:fld>
             <a:endParaRPr lang="en-US"/>
           </a:p>
@@ -1693,6 +1504,11 @@
 <file path=ppt/slideMasters/slideMaster1.xml><?xml version="1.0" encoding="utf-8"?>
 <p:sldMaster xmlns:a="http://schemas.openxmlformats.org/drawingml/2006/main" xmlns:r="http://schemas.openxmlformats.org/officeDocument/2006/relationships" xmlns:p="http://schemas.openxmlformats.org/presentationml/2006/main">
   <p:cSld>
+    <p:bg>
+      <p:bgRef idx="1001">
+        <a:schemeClr val="bg1"/>
+      </p:bgRef>
+    </p:bg>
     <p:spTree>
       <p:nvGrpSpPr>
         <p:cNvPr id="1" name=""/>
@@ -1727,7 +1543,7 @@
           </a:prstGeom>
           <a:extLst>
             <a:ext uri="{C572A759-6A51-4108-AA02-DFA0A04FC94B}">
-              <ma14:wrappingTextBoxFlag xmlns:ma14="http://schemas.microsoft.com/office/mac/drawingml/2011/main" val="0"/>
+              <ma14:wrappingTextBoxFlag xmlns:ma14="http://schemas.microsoft.com/office/mac/drawingml/2011/main" xmlns="" val="0"/>
             </a:ext>
           </a:extLst>
         </p:spPr>
@@ -1745,8 +1561,8 @@
           <a:p>
             <a:pPr algn="r"/>
             <a:fld id="{F7021451-1387-4CA6-816F-3879F97B5CBC}" type="slidenum">
-              <a:rPr b="0" lang="en-US"/>
-              <a:t>null</a:t>
+              <a:rPr lang="en-US" b="0"/>
+              <a:t>‹#›</a:t>
             </a:fld>
             <a:endParaRPr lang="en-US"/>
           </a:p>
@@ -2034,9 +1850,11 @@
       <p:sp>
         <p:nvSpPr>
           <p:cNvPr id="2" name="Text 0"/>
-          <p:cNvSpPr/>
+          <p:cNvSpPr>
+            <a:spLocks noGrp="1"/>
+          </p:cNvSpPr>
           <p:nvPr>
-            <p:ph idx="100" type="title" hasCustomPrompt="1"/>
+            <p:ph type="title" idx="100" hasCustomPrompt="1"/>
           </p:nvPr>
         </p:nvSpPr>
         <p:spPr>
@@ -2054,7 +1872,7 @@
           <a:bodyPr wrap="square" lIns="0" tIns="0" rIns="0" bIns="0" rtlCol="0" anchor="b"/>
           <a:lstStyle/>
           <a:p>
-            <a:pPr algn="l" indent="0" marL="0">
+            <a:pPr marL="0" indent="0" algn="l">
               <a:buNone/>
             </a:pPr>
             <a:r>
@@ -2075,9 +1893,11 @@
       <p:sp>
         <p:nvSpPr>
           <p:cNvPr id="3" name="Text 0"/>
-          <p:cNvSpPr/>
+          <p:cNvSpPr>
+            <a:spLocks noGrp="1"/>
+          </p:cNvSpPr>
           <p:nvPr>
-            <p:ph idx="101" type="body" hasCustomPrompt="1"/>
+            <p:ph type="body" idx="101" hasCustomPrompt="1"/>
           </p:nvPr>
         </p:nvSpPr>
         <p:spPr>
@@ -2095,7 +1915,7 @@
           <a:bodyPr wrap="square" lIns="0" tIns="0" rIns="0" bIns="0" rtlCol="0" anchor="t"/>
           <a:lstStyle/>
           <a:p>
-            <a:pPr indent="0" marL="0">
+            <a:pPr marL="0" indent="0">
               <a:buNone/>
             </a:pPr>
             <a:r>
@@ -2156,7 +1976,7 @@
           <a:bodyPr wrap="square" lIns="0" tIns="0" rIns="0" bIns="0" rtlCol="0" anchor="ctr"/>
           <a:lstStyle/>
           <a:p>
-            <a:pPr algn="ctr" indent="0" marL="0">
+            <a:pPr marL="0" indent="0" algn="ctr">
               <a:buNone/>
             </a:pPr>
             <a:r>
@@ -2217,7 +2037,7 @@
           <a:bodyPr wrap="square" lIns="0" tIns="0" rIns="0" bIns="0" rtlCol="0" anchor="ctr"/>
           <a:lstStyle/>
           <a:p>
-            <a:pPr algn="ctr" indent="0" marL="0">
+            <a:pPr marL="0" indent="0" algn="ctr">
               <a:buNone/>
             </a:pPr>
             <a:r>
@@ -2278,7 +2098,7 @@
           <a:bodyPr wrap="square" lIns="0" tIns="0" rIns="0" bIns="0" rtlCol="0" anchor="ctr"/>
           <a:lstStyle/>
           <a:p>
-            <a:pPr algn="ctr" indent="0" marL="0">
+            <a:pPr marL="0" indent="0" algn="ctr">
               <a:buNone/>
             </a:pPr>
             <a:r>
@@ -2339,7 +2159,7 @@
           <a:bodyPr wrap="square" lIns="0" tIns="0" rIns="0" bIns="0" rtlCol="0" anchor="ctr"/>
           <a:lstStyle/>
           <a:p>
-            <a:pPr algn="ctr" indent="0" marL="0">
+            <a:pPr marL="0" indent="0" algn="ctr">
               <a:buNone/>
             </a:pPr>
             <a:r>
@@ -2400,7 +2220,7 @@
           <a:bodyPr wrap="square" lIns="0" tIns="0" rIns="0" bIns="0" rtlCol="0" anchor="ctr"/>
           <a:lstStyle/>
           <a:p>
-            <a:pPr algn="ctr" indent="0" marL="0">
+            <a:pPr marL="0" indent="0" algn="ctr">
               <a:buNone/>
             </a:pPr>
             <a:r>
@@ -2461,7 +2281,7 @@
           <a:bodyPr wrap="square" lIns="0" tIns="0" rIns="0" bIns="0" rtlCol="0" anchor="ctr"/>
           <a:lstStyle/>
           <a:p>
-            <a:pPr algn="ctr" indent="0" marL="0">
+            <a:pPr marL="0" indent="0" algn="ctr">
               <a:buNone/>
             </a:pPr>
             <a:r>
@@ -2522,7 +2342,7 @@
           <a:bodyPr wrap="square" lIns="0" tIns="0" rIns="0" bIns="0" rtlCol="0" anchor="ctr"/>
           <a:lstStyle/>
           <a:p>
-            <a:pPr algn="ctr" indent="0" marL="0">
+            <a:pPr marL="0" indent="0" algn="ctr">
               <a:buNone/>
             </a:pPr>
             <a:r>
@@ -2583,7 +2403,7 @@
           <a:bodyPr wrap="square" lIns="0" tIns="0" rIns="0" bIns="0" rtlCol="0" anchor="ctr"/>
           <a:lstStyle/>
           <a:p>
-            <a:pPr algn="ctr" indent="0" marL="0">
+            <a:pPr marL="0" indent="0" algn="ctr">
               <a:buNone/>
             </a:pPr>
             <a:r>
@@ -2619,7 +2439,7 @@
           <a:bodyPr wrap="square" lIns="0" tIns="0" rIns="0" bIns="0" rtlCol="0" anchor="ctr"/>
           <a:lstStyle/>
           <a:p>
-            <a:pPr indent="0" marL="0">
+            <a:pPr marL="0" indent="0">
               <a:buNone/>
             </a:pPr>
             <a:r>
@@ -2680,7 +2500,7 @@
           <a:bodyPr wrap="square" lIns="0" tIns="0" rIns="0" bIns="0" rtlCol="0" anchor="ctr"/>
           <a:lstStyle/>
           <a:p>
-            <a:pPr indent="0" marL="0">
+            <a:pPr marL="0" indent="0">
               <a:buNone/>
             </a:pPr>
             <a:r>
@@ -2746,7 +2566,7 @@
           <a:bodyPr wrap="square" lIns="0" tIns="0" rIns="0" bIns="0" rtlCol="0" anchor="t"/>
           <a:lstStyle/>
           <a:p>
-            <a:pPr indent="0" marL="0">
+            <a:pPr marL="0" indent="0">
               <a:buNone/>
             </a:pPr>
             <a:r>
@@ -2760,7 +2580,7 @@
             <a:endParaRPr lang="en-US" sz="1400" dirty="0"/>
           </a:p>
           <a:p>
-            <a:pPr indent="0" marL="0">
+            <a:pPr marL="0" indent="0">
               <a:buNone/>
             </a:pPr>
             <a:r>
@@ -2823,7 +2643,7 @@
           <a:bodyPr wrap="square" lIns="0" tIns="0" rIns="0" bIns="0" rtlCol="0" anchor="t"/>
           <a:lstStyle/>
           <a:p>
-            <a:pPr indent="0" marL="0">
+            <a:pPr marL="0" indent="0">
               <a:buNone/>
             </a:pPr>
             <a:r>
@@ -2837,7 +2657,7 @@
             <a:endParaRPr lang="en-US" sz="1400" dirty="0"/>
           </a:p>
           <a:p>
-            <a:pPr indent="0" marL="0">
+            <a:pPr marL="0" indent="0">
               <a:buNone/>
             </a:pPr>
             <a:r>
@@ -2900,7 +2720,7 @@
           <a:bodyPr wrap="square" lIns="0" tIns="0" rIns="0" bIns="0" rtlCol="0" anchor="t"/>
           <a:lstStyle/>
           <a:p>
-            <a:pPr indent="0" marL="0">
+            <a:pPr marL="0" indent="0">
               <a:buNone/>
             </a:pPr>
             <a:r>
@@ -2914,7 +2734,7 @@
             <a:endParaRPr lang="en-US" sz="1400" dirty="0"/>
           </a:p>
           <a:p>
-            <a:pPr indent="0" marL="0">
+            <a:pPr marL="0" indent="0">
               <a:buNone/>
             </a:pPr>
             <a:r>
@@ -2977,7 +2797,7 @@
           <a:bodyPr wrap="square" lIns="0" tIns="0" rIns="0" bIns="0" rtlCol="0" anchor="t"/>
           <a:lstStyle/>
           <a:p>
-            <a:pPr indent="0" marL="0">
+            <a:pPr marL="0" indent="0">
               <a:buNone/>
             </a:pPr>
             <a:r>
@@ -2991,7 +2811,7 @@
             <a:endParaRPr lang="en-US" sz="1400" dirty="0"/>
           </a:p>
           <a:p>
-            <a:pPr indent="0" marL="0">
+            <a:pPr marL="0" indent="0">
               <a:buNone/>
             </a:pPr>
             <a:r>
@@ -3027,7 +2847,7 @@
           <a:bodyPr wrap="square" lIns="0" tIns="0" rIns="0" bIns="0" rtlCol="0" anchor="ctr"/>
           <a:lstStyle/>
           <a:p>
-            <a:pPr indent="0" marL="0">
+            <a:pPr marL="0" indent="0">
               <a:buNone/>
             </a:pPr>
             <a:r>
@@ -3039,66 +2859,6 @@
               <a:t>Evidence for every module: docs/EVIDENCE.md · github.com/Ishan007-bot/Bloodlink</a:t>
             </a:r>
             <a:endParaRPr lang="en-US" sz="1300" dirty="0"/>
-          </a:p>
-        </p:txBody>
-      </p:sp>
-      <p:sp>
-        <p:nvSpPr>
-          <p:cNvPr id="13" name="Text 0"/>
-          <p:cNvSpPr/>
-          <p:nvPr>
-            <p:ph idx="100" type="title" hasCustomPrompt="1"/>
-          </p:nvPr>
-        </p:nvSpPr>
-        <p:spPr>
-          <a:xfrm>
-            <a:off x="548640" y="1234440"/>
-            <a:ext cx="8046720" cy="914400"/>
-          </a:xfrm>
-          <a:prstGeom prst="rect">
-            <a:avLst/>
-          </a:prstGeom>
-          <a:noFill/>
-          <a:ln/>
-        </p:spPr>
-        <p:txBody>
-          <a:bodyPr wrap="square" lIns="0" tIns="0" rIns="0" bIns="0" rtlCol="0" anchor="b"/>
-          <a:lstStyle/>
-          <a:p>
-            <a:pPr algn="l" indent="0" marL="0">
-              <a:buNone/>
-            </a:pPr>
-            <a:endParaRPr lang="en-US" sz="4400" dirty="0"/>
-          </a:p>
-        </p:txBody>
-      </p:sp>
-      <p:sp>
-        <p:nvSpPr>
-          <p:cNvPr id="14" name="Text 0"/>
-          <p:cNvSpPr/>
-          <p:nvPr>
-            <p:ph idx="101" type="body" hasCustomPrompt="1"/>
-          </p:nvPr>
-        </p:nvSpPr>
-        <p:spPr>
-          <a:xfrm>
-            <a:off x="548640" y="2240280"/>
-            <a:ext cx="8046720" cy="822960"/>
-          </a:xfrm>
-          <a:prstGeom prst="rect">
-            <a:avLst/>
-          </a:prstGeom>
-          <a:noFill/>
-          <a:ln/>
-        </p:spPr>
-        <p:txBody>
-          <a:bodyPr wrap="square" lIns="0" tIns="0" rIns="0" bIns="0" rtlCol="0" anchor="t"/>
-          <a:lstStyle/>
-          <a:p>
-            <a:pPr indent="0" marL="0">
-              <a:buNone/>
-            </a:pPr>
-            <a:endParaRPr lang="en-US" sz="1800" dirty="0"/>
           </a:p>
         </p:txBody>
       </p:sp>
@@ -3130,9 +2890,11 @@
       <p:sp>
         <p:nvSpPr>
           <p:cNvPr id="2" name="Text 0"/>
-          <p:cNvSpPr/>
+          <p:cNvSpPr>
+            <a:spLocks noGrp="1"/>
+          </p:cNvSpPr>
           <p:nvPr>
-            <p:ph idx="100" type="title" hasCustomPrompt="1"/>
+            <p:ph type="title" idx="100" hasCustomPrompt="1"/>
           </p:nvPr>
         </p:nvSpPr>
         <p:spPr>
@@ -3150,7 +2912,7 @@
           <a:bodyPr wrap="square" lIns="0" tIns="0" rIns="0" bIns="0" rtlCol="0" anchor="ctr"/>
           <a:lstStyle/>
           <a:p>
-            <a:pPr algn="l" indent="0" marL="0">
+            <a:pPr marL="0" indent="0" algn="l">
               <a:buNone/>
             </a:pPr>
             <a:r>
@@ -3214,7 +2976,7 @@
           <a:bodyPr wrap="square" lIns="0" tIns="0" rIns="0" bIns="0" rtlCol="0" anchor="ctr"/>
           <a:lstStyle/>
           <a:p>
-            <a:pPr algn="ctr" indent="0" marL="0">
+            <a:pPr marL="0" indent="0" algn="ctr">
               <a:buNone/>
             </a:pPr>
             <a:r>
@@ -3250,7 +3012,7 @@
           <a:bodyPr wrap="square" lIns="0" tIns="0" rIns="0" bIns="0" rtlCol="0" anchor="t"/>
           <a:lstStyle/>
           <a:p>
-            <a:pPr indent="0" marL="0">
+            <a:pPr marL="0" indent="0">
               <a:buNone/>
             </a:pPr>
             <a:r>
@@ -3264,7 +3026,7 @@
             <a:endParaRPr lang="en-US" sz="1500" dirty="0"/>
           </a:p>
           <a:p>
-            <a:pPr indent="0" marL="0">
+            <a:pPr marL="0" indent="0">
               <a:buNone/>
             </a:pPr>
             <a:r>
@@ -3325,7 +3087,7 @@
           <a:bodyPr wrap="square" lIns="0" tIns="0" rIns="0" bIns="0" rtlCol="0" anchor="ctr"/>
           <a:lstStyle/>
           <a:p>
-            <a:pPr algn="ctr" indent="0" marL="0">
+            <a:pPr marL="0" indent="0" algn="ctr">
               <a:buNone/>
             </a:pPr>
             <a:r>
@@ -3361,7 +3123,7 @@
           <a:bodyPr wrap="square" lIns="0" tIns="0" rIns="0" bIns="0" rtlCol="0" anchor="t"/>
           <a:lstStyle/>
           <a:p>
-            <a:pPr indent="0" marL="0">
+            <a:pPr marL="0" indent="0">
               <a:buNone/>
             </a:pPr>
             <a:r>
@@ -3375,7 +3137,7 @@
             <a:endParaRPr lang="en-US" sz="1500" dirty="0"/>
           </a:p>
           <a:p>
-            <a:pPr indent="0" marL="0">
+            <a:pPr marL="0" indent="0">
               <a:buNone/>
             </a:pPr>
             <a:r>
@@ -3436,7 +3198,7 @@
           <a:bodyPr wrap="square" lIns="0" tIns="0" rIns="0" bIns="0" rtlCol="0" anchor="ctr"/>
           <a:lstStyle/>
           <a:p>
-            <a:pPr algn="ctr" indent="0" marL="0">
+            <a:pPr marL="0" indent="0" algn="ctr">
               <a:buNone/>
             </a:pPr>
             <a:r>
@@ -3472,7 +3234,7 @@
           <a:bodyPr wrap="square" lIns="0" tIns="0" rIns="0" bIns="0" rtlCol="0" anchor="t"/>
           <a:lstStyle/>
           <a:p>
-            <a:pPr indent="0" marL="0">
+            <a:pPr marL="0" indent="0">
               <a:buNone/>
             </a:pPr>
             <a:r>
@@ -3486,7 +3248,7 @@
             <a:endParaRPr lang="en-US" sz="1500" dirty="0"/>
           </a:p>
           <a:p>
-            <a:pPr indent="0" marL="0">
+            <a:pPr marL="0" indent="0">
               <a:buNone/>
             </a:pPr>
             <a:r>
@@ -3527,7 +3289,7 @@
             <a:prstDash val="solid"/>
           </a:ln>
           <a:effectLst>
-            <a:outerShdw sx="100000" sy="100000" kx="0" ky="0" algn="bl" rotWithShape="0" blurRad="76200" dist="25400" dir="5400000">
+            <a:outerShdw blurRad="76200" dist="25400" dir="5400000" algn="bl" rotWithShape="0">
               <a:srgbClr val="000000">
                 <a:alpha val="18000"/>
               </a:srgbClr>
@@ -3537,14 +3299,14 @@
       </p:sp>
       <p:pic>
         <p:nvPicPr>
-          <p:cNvPr id="13" name="BloodLink dashboard" descr="BloodLink dashboard">    </p:cNvPr>
+          <p:cNvPr id="13" name="BloodLink dashboard" descr="BloodLink dashboard"/>
           <p:cNvPicPr>
             <a:picLocks noChangeAspect="1"/>
           </p:cNvPicPr>
           <p:nvPr/>
         </p:nvPicPr>
         <p:blipFill>
-          <a:blip r:embed="rId1"/>
+          <a:blip r:embed="rId3"/>
           <a:stretch>
             <a:fillRect/>
           </a:stretch>
@@ -3580,7 +3342,7 @@
           <a:bodyPr wrap="square" lIns="0" tIns="0" rIns="0" bIns="0" rtlCol="0" anchor="ctr"/>
           <a:lstStyle/>
           <a:p>
-            <a:pPr indent="0" marL="0">
+            <a:pPr marL="0" indent="0">
               <a:buNone/>
             </a:pPr>
             <a:r>
@@ -3615,7 +3377,7 @@
           </a:prstGeom>
           <a:extLst>
             <a:ext uri="{C572A759-6A51-4108-AA02-DFA0A04FC94B}">
-              <ma14:wrappingTextBoxFlag xmlns:ma14="http://schemas.microsoft.com/office/mac/drawingml/2011/main" val="0"/>
+              <ma14:wrappingTextBoxFlag xmlns:ma14="http://schemas.microsoft.com/office/mac/drawingml/2011/main" xmlns="" val="0"/>
             </a:ext>
           </a:extLst>
         </p:spPr>
@@ -3633,7 +3395,7 @@
           <a:p>
             <a:pPr algn="r"/>
             <a:fld id="{F7021451-1387-4CA6-816F-3879F97B5CBC}" type="slidenum">
-              <a:rPr b="0" lang="en-US"/>
+              <a:rPr lang="en-US" b="0"/>
               <a:t>2</a:t>
             </a:fld>
             <a:endParaRPr lang="en-US"/>
@@ -3668,9 +3430,11 @@
       <p:sp>
         <p:nvSpPr>
           <p:cNvPr id="2" name="Text 0"/>
-          <p:cNvSpPr/>
+          <p:cNvSpPr>
+            <a:spLocks noGrp="1"/>
+          </p:cNvSpPr>
           <p:nvPr>
-            <p:ph idx="100" type="title" hasCustomPrompt="1"/>
+            <p:ph type="title" idx="100" hasCustomPrompt="1"/>
           </p:nvPr>
         </p:nvSpPr>
         <p:spPr>
@@ -3688,7 +3452,7 @@
           <a:bodyPr wrap="square" lIns="0" tIns="0" rIns="0" bIns="0" rtlCol="0" anchor="ctr"/>
           <a:lstStyle/>
           <a:p>
-            <a:pPr algn="l" indent="0" marL="0">
+            <a:pPr marL="0" indent="0" algn="l">
               <a:buNone/>
             </a:pPr>
             <a:r>
@@ -3754,7 +3518,7 @@
           <a:bodyPr wrap="square" lIns="0" tIns="0" rIns="0" bIns="0" rtlCol="0" anchor="t"/>
           <a:lstStyle/>
           <a:p>
-            <a:pPr indent="0" marL="0">
+            <a:pPr marL="0" indent="0">
               <a:buNone/>
             </a:pPr>
             <a:r>
@@ -3768,7 +3532,7 @@
             <a:endParaRPr lang="en-US" sz="1500" dirty="0"/>
           </a:p>
           <a:p>
-            <a:pPr indent="0" marL="0">
+            <a:pPr marL="0" indent="0">
               <a:buNone/>
             </a:pPr>
             <a:r>
@@ -3856,7 +3620,7 @@
           <a:bodyPr wrap="square" lIns="0" tIns="0" rIns="0" bIns="0" rtlCol="0" anchor="t"/>
           <a:lstStyle/>
           <a:p>
-            <a:pPr indent="0" marL="0">
+            <a:pPr marL="0" indent="0">
               <a:buNone/>
             </a:pPr>
             <a:r>
@@ -3870,7 +3634,7 @@
             <a:endParaRPr lang="en-US" sz="1500" dirty="0"/>
           </a:p>
           <a:p>
-            <a:pPr indent="0" marL="0">
+            <a:pPr marL="0" indent="0">
               <a:buNone/>
             </a:pPr>
             <a:r>
@@ -3958,7 +3722,7 @@
           <a:bodyPr wrap="square" lIns="0" tIns="0" rIns="0" bIns="0" rtlCol="0" anchor="t"/>
           <a:lstStyle/>
           <a:p>
-            <a:pPr indent="0" marL="0">
+            <a:pPr marL="0" indent="0">
               <a:buNone/>
             </a:pPr>
             <a:r>
@@ -3972,7 +3736,7 @@
             <a:endParaRPr lang="en-US" sz="1500" dirty="0"/>
           </a:p>
           <a:p>
-            <a:pPr indent="0" marL="0">
+            <a:pPr marL="0" indent="0">
               <a:buNone/>
             </a:pPr>
             <a:r>
@@ -4060,7 +3824,7 @@
           <a:bodyPr wrap="square" lIns="0" tIns="0" rIns="0" bIns="0" rtlCol="0" anchor="t"/>
           <a:lstStyle/>
           <a:p>
-            <a:pPr indent="0" marL="0">
+            <a:pPr marL="0" indent="0">
               <a:buNone/>
             </a:pPr>
             <a:r>
@@ -4074,7 +3838,7 @@
             <a:endParaRPr lang="en-US" sz="1500" dirty="0"/>
           </a:p>
           <a:p>
-            <a:pPr indent="0" marL="0">
+            <a:pPr marL="0" indent="0">
               <a:buNone/>
             </a:pPr>
             <a:r>
@@ -4162,7 +3926,7 @@
           <a:bodyPr wrap="square" lIns="0" tIns="0" rIns="0" bIns="0" rtlCol="0" anchor="t"/>
           <a:lstStyle/>
           <a:p>
-            <a:pPr indent="0" marL="0">
+            <a:pPr marL="0" indent="0">
               <a:buNone/>
             </a:pPr>
             <a:r>
@@ -4176,7 +3940,7 @@
             <a:endParaRPr lang="en-US" sz="1500" dirty="0"/>
           </a:p>
           <a:p>
-            <a:pPr indent="0" marL="0">
+            <a:pPr marL="0" indent="0">
               <a:buNone/>
             </a:pPr>
             <a:r>
@@ -4212,7 +3976,7 @@
           <a:bodyPr wrap="square" lIns="0" tIns="0" rIns="0" bIns="0" rtlCol="0" anchor="ctr"/>
           <a:lstStyle/>
           <a:p>
-            <a:pPr indent="0" marL="0">
+            <a:pPr marL="0" indent="0">
               <a:buNone/>
             </a:pPr>
             <a:r>
@@ -4251,7 +4015,7 @@
           <a:bodyPr wrap="square" lIns="0" tIns="0" rIns="0" bIns="0" rtlCol="0" anchor="t"/>
           <a:lstStyle/>
           <a:p>
-            <a:pPr indent="0" marL="0">
+            <a:pPr marL="0" indent="0">
               <a:buNone/>
             </a:pPr>
             <a:r>
@@ -4287,7 +4051,7 @@
           <a:bodyPr wrap="square" lIns="0" tIns="0" rIns="0" bIns="0" rtlCol="0" anchor="ctr"/>
           <a:lstStyle/>
           <a:p>
-            <a:pPr indent="0" marL="0">
+            <a:pPr marL="0" indent="0">
               <a:buNone/>
             </a:pPr>
             <a:r>
@@ -4326,7 +4090,7 @@
           <a:bodyPr wrap="square" lIns="0" tIns="0" rIns="0" bIns="0" rtlCol="0" anchor="t"/>
           <a:lstStyle/>
           <a:p>
-            <a:pPr indent="0" marL="0">
+            <a:pPr marL="0" indent="0">
               <a:buNone/>
             </a:pPr>
             <a:r>
@@ -4362,7 +4126,7 @@
           <a:bodyPr wrap="square" lIns="0" tIns="0" rIns="0" bIns="0" rtlCol="0" anchor="ctr"/>
           <a:lstStyle/>
           <a:p>
-            <a:pPr indent="0" marL="0">
+            <a:pPr marL="0" indent="0">
               <a:buNone/>
             </a:pPr>
             <a:r>
@@ -4401,7 +4165,7 @@
           <a:bodyPr wrap="square" lIns="0" tIns="0" rIns="0" bIns="0" rtlCol="0" anchor="t"/>
           <a:lstStyle/>
           <a:p>
-            <a:pPr indent="0" marL="0">
+            <a:pPr marL="0" indent="0">
               <a:buNone/>
             </a:pPr>
             <a:r>
@@ -4436,7 +4200,7 @@
           </a:prstGeom>
           <a:extLst>
             <a:ext uri="{C572A759-6A51-4108-AA02-DFA0A04FC94B}">
-              <ma14:wrappingTextBoxFlag xmlns:ma14="http://schemas.microsoft.com/office/mac/drawingml/2011/main" val="0"/>
+              <ma14:wrappingTextBoxFlag xmlns:ma14="http://schemas.microsoft.com/office/mac/drawingml/2011/main" xmlns="" val="0"/>
             </a:ext>
           </a:extLst>
         </p:spPr>
@@ -4454,7 +4218,7 @@
           <a:p>
             <a:pPr algn="r"/>
             <a:fld id="{F7021451-1387-4CA6-816F-3879F97B5CBC}" type="slidenum">
-              <a:rPr b="0" lang="en-US"/>
+              <a:rPr lang="en-US" b="0"/>
               <a:t>3</a:t>
             </a:fld>
             <a:endParaRPr lang="en-US"/>
@@ -4489,9 +4253,11 @@
       <p:sp>
         <p:nvSpPr>
           <p:cNvPr id="2" name="Text 0"/>
-          <p:cNvSpPr/>
+          <p:cNvSpPr>
+            <a:spLocks noGrp="1"/>
+          </p:cNvSpPr>
           <p:nvPr>
-            <p:ph idx="100" type="title" hasCustomPrompt="1"/>
+            <p:ph type="title" idx="100" hasCustomPrompt="1"/>
           </p:nvPr>
         </p:nvSpPr>
         <p:spPr>
@@ -4509,7 +4275,7 @@
           <a:bodyPr wrap="square" lIns="0" tIns="0" rIns="0" bIns="0" rtlCol="0" anchor="ctr"/>
           <a:lstStyle/>
           <a:p>
-            <a:pPr algn="l" indent="0" marL="0">
+            <a:pPr marL="0" indent="0" algn="l">
               <a:buNone/>
             </a:pPr>
             <a:r>
@@ -4548,7 +4314,7 @@
           <a:bodyPr wrap="square" lIns="0" tIns="0" rIns="0" bIns="0" rtlCol="0" anchor="t"/>
           <a:lstStyle/>
           <a:p>
-            <a:pPr indent="0" marL="0">
+            <a:pPr marL="0" indent="0">
               <a:buNone/>
             </a:pPr>
             <a:r>
@@ -4562,7 +4328,7 @@
             <a:endParaRPr lang="en-US" sz="1500" dirty="0"/>
           </a:p>
           <a:p>
-            <a:pPr indent="0" marL="0">
+            <a:pPr marL="0" indent="0">
               <a:buNone/>
             </a:pPr>
             <a:r>
@@ -4623,7 +4389,7 @@
           <a:bodyPr wrap="square" lIns="0" tIns="0" rIns="0" bIns="0" rtlCol="0" anchor="ctr"/>
           <a:lstStyle/>
           <a:p>
-            <a:pPr algn="ctr" indent="0" marL="0">
+            <a:pPr marL="0" indent="0" algn="ctr">
               <a:buNone/>
             </a:pPr>
             <a:r>
@@ -4659,7 +4425,7 @@
           <a:bodyPr wrap="square" lIns="0" tIns="0" rIns="0" bIns="0" rtlCol="0" anchor="t"/>
           <a:lstStyle/>
           <a:p>
-            <a:pPr indent="0" marL="0">
+            <a:pPr marL="0" indent="0">
               <a:buNone/>
             </a:pPr>
             <a:r>
@@ -4673,7 +4439,7 @@
             <a:endParaRPr lang="en-US" sz="1500" dirty="0"/>
           </a:p>
           <a:p>
-            <a:pPr indent="0" marL="0">
+            <a:pPr marL="0" indent="0">
               <a:buNone/>
             </a:pPr>
             <a:r>
@@ -4734,7 +4500,7 @@
           <a:bodyPr wrap="square" lIns="0" tIns="0" rIns="0" bIns="0" rtlCol="0" anchor="ctr"/>
           <a:lstStyle/>
           <a:p>
-            <a:pPr algn="ctr" indent="0" marL="0">
+            <a:pPr marL="0" indent="0" algn="ctr">
               <a:buNone/>
             </a:pPr>
             <a:r>
@@ -4770,7 +4536,7 @@
           <a:bodyPr wrap="square" lIns="0" tIns="0" rIns="0" bIns="0" rtlCol="0" anchor="t"/>
           <a:lstStyle/>
           <a:p>
-            <a:pPr indent="0" marL="0">
+            <a:pPr marL="0" indent="0">
               <a:buNone/>
             </a:pPr>
             <a:r>
@@ -4784,7 +4550,7 @@
             <a:endParaRPr lang="en-US" sz="1500" dirty="0"/>
           </a:p>
           <a:p>
-            <a:pPr indent="0" marL="0">
+            <a:pPr marL="0" indent="0">
               <a:buNone/>
             </a:pPr>
             <a:r>
@@ -4845,7 +4611,7 @@
           <a:bodyPr wrap="square" lIns="0" tIns="0" rIns="0" bIns="0" rtlCol="0" anchor="ctr"/>
           <a:lstStyle/>
           <a:p>
-            <a:pPr algn="ctr" indent="0" marL="0">
+            <a:pPr marL="0" indent="0" algn="ctr">
               <a:buNone/>
             </a:pPr>
             <a:r>
@@ -4881,7 +4647,7 @@
           <a:bodyPr wrap="square" lIns="0" tIns="0" rIns="0" bIns="0" rtlCol="0" anchor="t"/>
           <a:lstStyle/>
           <a:p>
-            <a:pPr indent="0" marL="0">
+            <a:pPr marL="0" indent="0">
               <a:buNone/>
             </a:pPr>
             <a:r>
@@ -4895,7 +4661,7 @@
             <a:endParaRPr lang="en-US" sz="1500" dirty="0"/>
           </a:p>
           <a:p>
-            <a:pPr indent="0" marL="0">
+            <a:pPr marL="0" indent="0">
               <a:buNone/>
             </a:pPr>
             <a:r>
@@ -4936,7 +4702,7 @@
             <a:prstDash val="solid"/>
           </a:ln>
           <a:effectLst>
-            <a:outerShdw sx="100000" sy="100000" kx="0" ky="0" algn="bl" rotWithShape="0" blurRad="76200" dist="25400" dir="5400000">
+            <a:outerShdw blurRad="76200" dist="25400" dir="5400000" algn="bl" rotWithShape="0">
               <a:srgbClr val="000000">
                 <a:alpha val="18000"/>
               </a:srgbClr>
@@ -4946,14 +4712,14 @@
       </p:sp>
       <p:pic>
         <p:nvPicPr>
-          <p:cNvPr id="14" name="Pipeline blocked by failing test" descr="Pipeline blocked by failing test">    </p:cNvPr>
+          <p:cNvPr id="14" name="Pipeline blocked by failing test" descr="Pipeline blocked by failing test"/>
           <p:cNvPicPr>
             <a:picLocks noChangeAspect="1"/>
           </p:cNvPicPr>
           <p:nvPr/>
         </p:nvPicPr>
         <p:blipFill>
-          <a:blip r:embed="rId1"/>
+          <a:blip r:embed="rId3"/>
           <a:stretch>
             <a:fillRect/>
           </a:stretch>
@@ -4989,7 +4755,7 @@
           <a:bodyPr wrap="square" lIns="0" tIns="0" rIns="0" bIns="0" rtlCol="0" anchor="ctr"/>
           <a:lstStyle/>
           <a:p>
-            <a:pPr indent="0" marL="0">
+            <a:pPr marL="0" indent="0">
               <a:buNone/>
             </a:pPr>
             <a:r>
@@ -5024,7 +4790,7 @@
           </a:prstGeom>
           <a:extLst>
             <a:ext uri="{C572A759-6A51-4108-AA02-DFA0A04FC94B}">
-              <ma14:wrappingTextBoxFlag xmlns:ma14="http://schemas.microsoft.com/office/mac/drawingml/2011/main" val="0"/>
+              <ma14:wrappingTextBoxFlag xmlns:ma14="http://schemas.microsoft.com/office/mac/drawingml/2011/main" xmlns="" val="0"/>
             </a:ext>
           </a:extLst>
         </p:spPr>
@@ -5042,7 +4808,7 @@
           <a:p>
             <a:pPr algn="r"/>
             <a:fld id="{F7021451-1387-4CA6-816F-3879F97B5CBC}" type="slidenum">
-              <a:rPr b="0" lang="en-US"/>
+              <a:rPr lang="en-US" b="0"/>
               <a:t>4</a:t>
             </a:fld>
             <a:endParaRPr lang="en-US"/>
@@ -5077,9 +4843,11 @@
       <p:sp>
         <p:nvSpPr>
           <p:cNvPr id="2" name="Text 0"/>
-          <p:cNvSpPr/>
+          <p:cNvSpPr>
+            <a:spLocks noGrp="1"/>
+          </p:cNvSpPr>
           <p:nvPr>
-            <p:ph idx="100" type="title" hasCustomPrompt="1"/>
+            <p:ph type="title" idx="100" hasCustomPrompt="1"/>
           </p:nvPr>
         </p:nvSpPr>
         <p:spPr>
@@ -5097,7 +4865,7 @@
           <a:bodyPr wrap="square" lIns="0" tIns="0" rIns="0" bIns="0" rtlCol="0" anchor="ctr"/>
           <a:lstStyle/>
           <a:p>
-            <a:pPr algn="l" indent="0" marL="0">
+            <a:pPr marL="0" indent="0" algn="l">
               <a:buNone/>
             </a:pPr>
             <a:r>
@@ -5136,7 +4904,7 @@
           <a:bodyPr wrap="square" lIns="0" tIns="0" rIns="0" bIns="0" rtlCol="0" anchor="ctr"/>
           <a:lstStyle/>
           <a:p>
-            <a:pPr indent="0" marL="0">
+            <a:pPr marL="0" indent="0">
               <a:buNone/>
             </a:pPr>
             <a:r>
@@ -5175,7 +4943,7 @@
           <a:bodyPr wrap="square" lIns="0" tIns="0" rIns="0" bIns="0" rtlCol="0" anchor="t"/>
           <a:lstStyle/>
           <a:p>
-            <a:pPr indent="0" marL="0">
+            <a:pPr marL="0" indent="0">
               <a:buNone/>
             </a:pPr>
             <a:r>
@@ -5211,7 +4979,7 @@
           <a:bodyPr wrap="square" lIns="0" tIns="0" rIns="0" bIns="0" rtlCol="0" anchor="ctr"/>
           <a:lstStyle/>
           <a:p>
-            <a:pPr indent="0" marL="0">
+            <a:pPr marL="0" indent="0">
               <a:buNone/>
             </a:pPr>
             <a:r>
@@ -5250,7 +5018,7 @@
           <a:bodyPr wrap="square" lIns="0" tIns="0" rIns="0" bIns="0" rtlCol="0" anchor="t"/>
           <a:lstStyle/>
           <a:p>
-            <a:pPr indent="0" marL="0">
+            <a:pPr marL="0" indent="0">
               <a:buNone/>
             </a:pPr>
             <a:r>
@@ -5286,7 +5054,7 @@
           <a:bodyPr wrap="square" lIns="0" tIns="0" rIns="0" bIns="0" rtlCol="0" anchor="t"/>
           <a:lstStyle/>
           <a:p>
-            <a:pPr indent="0" marL="0">
+            <a:pPr marL="0" indent="0">
               <a:buNone/>
             </a:pPr>
             <a:r>
@@ -5300,7 +5068,7 @@
             <a:endParaRPr lang="en-US" sz="1400" dirty="0"/>
           </a:p>
           <a:p>
-            <a:pPr indent="0" marL="0">
+            <a:pPr marL="0" indent="0">
               <a:buNone/>
             </a:pPr>
             <a:r>
@@ -5363,7 +5131,7 @@
           <a:bodyPr wrap="square" lIns="0" tIns="0" rIns="0" bIns="0" rtlCol="0" anchor="ctr"/>
           <a:lstStyle/>
           <a:p>
-            <a:pPr algn="ctr" indent="0" marL="0">
+            <a:pPr marL="0" indent="0" algn="ctr">
               <a:buNone/>
             </a:pPr>
             <a:r>
@@ -5426,7 +5194,7 @@
           <a:bodyPr wrap="square" lIns="0" tIns="0" rIns="0" bIns="0" rtlCol="0" anchor="ctr"/>
           <a:lstStyle/>
           <a:p>
-            <a:pPr algn="ctr" indent="0" marL="0">
+            <a:pPr marL="0" indent="0" algn="ctr">
               <a:buNone/>
             </a:pPr>
             <a:r>
@@ -5489,7 +5257,7 @@
           <a:bodyPr wrap="square" lIns="0" tIns="0" rIns="0" bIns="0" rtlCol="0" anchor="ctr"/>
           <a:lstStyle/>
           <a:p>
-            <a:pPr algn="ctr" indent="0" marL="0">
+            <a:pPr marL="0" indent="0" algn="ctr">
               <a:buNone/>
             </a:pPr>
             <a:r>
@@ -5552,7 +5320,7 @@
           <a:bodyPr wrap="square" lIns="0" tIns="0" rIns="0" bIns="0" rtlCol="0" anchor="ctr"/>
           <a:lstStyle/>
           <a:p>
-            <a:pPr algn="ctr" indent="0" marL="0">
+            <a:pPr marL="0" indent="0" algn="ctr">
               <a:buNone/>
             </a:pPr>
             <a:r>
@@ -5615,7 +5383,7 @@
           <a:bodyPr wrap="square" lIns="0" tIns="0" rIns="0" bIns="0" rtlCol="0" anchor="ctr"/>
           <a:lstStyle/>
           <a:p>
-            <a:pPr algn="ctr" indent="0" marL="0">
+            <a:pPr marL="0" indent="0" algn="ctr">
               <a:buNone/>
             </a:pPr>
             <a:r>
@@ -5678,7 +5446,7 @@
           <a:bodyPr wrap="square" lIns="0" tIns="0" rIns="0" bIns="0" rtlCol="0" anchor="ctr"/>
           <a:lstStyle/>
           <a:p>
-            <a:pPr algn="ctr" indent="0" marL="0">
+            <a:pPr marL="0" indent="0" algn="ctr">
               <a:buNone/>
             </a:pPr>
             <a:r>
@@ -5741,7 +5509,7 @@
           <a:bodyPr wrap="square" lIns="0" tIns="0" rIns="0" bIns="0" rtlCol="0" anchor="ctr"/>
           <a:lstStyle/>
           <a:p>
-            <a:pPr algn="ctr" indent="0" marL="0">
+            <a:pPr marL="0" indent="0" algn="ctr">
               <a:buNone/>
             </a:pPr>
             <a:r>
@@ -5804,7 +5572,7 @@
           <a:bodyPr wrap="square" lIns="0" tIns="0" rIns="0" bIns="0" rtlCol="0" anchor="ctr"/>
           <a:lstStyle/>
           <a:p>
-            <a:pPr algn="ctr" indent="0" marL="0">
+            <a:pPr marL="0" indent="0" algn="ctr">
               <a:buNone/>
             </a:pPr>
             <a:r>
@@ -5845,7 +5613,7 @@
             <a:prstDash val="solid"/>
           </a:ln>
           <a:effectLst>
-            <a:outerShdw sx="100000" sy="100000" kx="0" ky="0" algn="bl" rotWithShape="0" blurRad="76200" dist="25400" dir="5400000">
+            <a:outerShdw blurRad="76200" dist="25400" dir="5400000" algn="bl" rotWithShape="0">
               <a:srgbClr val="000000">
                 <a:alpha val="18000"/>
               </a:srgbClr>
@@ -5855,14 +5623,14 @@
       </p:sp>
       <p:pic>
         <p:nvPicPr>
-          <p:cNvPr id="25" name="Strict Trivy gate failing the old image" descr="Strict Trivy gate failing the old image">    </p:cNvPr>
+          <p:cNvPr id="25" name="Strict Trivy gate failing the old image" descr="Strict Trivy gate failing the old image"/>
           <p:cNvPicPr>
             <a:picLocks noChangeAspect="1"/>
           </p:cNvPicPr>
           <p:nvPr/>
         </p:nvPicPr>
         <p:blipFill>
-          <a:blip r:embed="rId1"/>
+          <a:blip r:embed="rId3"/>
           <a:stretch>
             <a:fillRect/>
           </a:stretch>
@@ -5879,7 +5647,7 @@
       </p:pic>
       <p:sp>
         <p:nvSpPr>
-          <p:cNvPr id="25" name="Slide Number Placeholder 0"/>
+          <p:cNvPr id="26" name="Slide Number Placeholder 0"/>
           <p:cNvSpPr>
             <a:spLocks noGrp="1"/>
           </p:cNvSpPr>
@@ -5897,7 +5665,7 @@
           </a:prstGeom>
           <a:extLst>
             <a:ext uri="{C572A759-6A51-4108-AA02-DFA0A04FC94B}">
-              <ma14:wrappingTextBoxFlag xmlns:ma14="http://schemas.microsoft.com/office/mac/drawingml/2011/main" val="0"/>
+              <ma14:wrappingTextBoxFlag xmlns:ma14="http://schemas.microsoft.com/office/mac/drawingml/2011/main" xmlns="" val="0"/>
             </a:ext>
           </a:extLst>
         </p:spPr>
@@ -5915,7 +5683,7 @@
           <a:p>
             <a:pPr algn="r"/>
             <a:fld id="{F7021451-1387-4CA6-816F-3879F97B5CBC}" type="slidenum">
-              <a:rPr b="0" lang="en-US"/>
+              <a:rPr lang="en-US" b="0"/>
               <a:t>5</a:t>
             </a:fld>
             <a:endParaRPr lang="en-US"/>
@@ -5950,9 +5718,11 @@
       <p:sp>
         <p:nvSpPr>
           <p:cNvPr id="2" name="Text 0"/>
-          <p:cNvSpPr/>
+          <p:cNvSpPr>
+            <a:spLocks noGrp="1"/>
+          </p:cNvSpPr>
           <p:nvPr>
-            <p:ph idx="100" type="title" hasCustomPrompt="1"/>
+            <p:ph type="title" idx="100" hasCustomPrompt="1"/>
           </p:nvPr>
         </p:nvSpPr>
         <p:spPr>
@@ -5970,7 +5740,7 @@
           <a:bodyPr wrap="square" lIns="0" tIns="0" rIns="0" bIns="0" rtlCol="0" anchor="ctr"/>
           <a:lstStyle/>
           <a:p>
-            <a:pPr algn="l" indent="0" marL="0">
+            <a:pPr marL="0" indent="0" algn="l">
               <a:buNone/>
             </a:pPr>
             <a:r>
@@ -6009,7 +5779,7 @@
           <a:bodyPr wrap="square" lIns="0" tIns="0" rIns="0" bIns="0" rtlCol="0" anchor="ctr"/>
           <a:lstStyle/>
           <a:p>
-            <a:pPr indent="0" marL="0">
+            <a:pPr marL="0" indent="0">
               <a:buNone/>
             </a:pPr>
             <a:r>
@@ -6048,7 +5818,7 @@
           <a:bodyPr wrap="square" lIns="0" tIns="0" rIns="0" bIns="0" rtlCol="0" anchor="t"/>
           <a:lstStyle/>
           <a:p>
-            <a:pPr indent="0" marL="0">
+            <a:pPr marL="0" indent="0">
               <a:buNone/>
             </a:pPr>
             <a:r>
@@ -6084,7 +5854,7 @@
           <a:bodyPr wrap="square" lIns="0" tIns="0" rIns="0" bIns="0" rtlCol="0" anchor="ctr"/>
           <a:lstStyle/>
           <a:p>
-            <a:pPr indent="0" marL="0">
+            <a:pPr marL="0" indent="0">
               <a:buNone/>
             </a:pPr>
             <a:r>
@@ -6123,7 +5893,7 @@
           <a:bodyPr wrap="square" lIns="0" tIns="0" rIns="0" bIns="0" rtlCol="0" anchor="t"/>
           <a:lstStyle/>
           <a:p>
-            <a:pPr indent="0" marL="0">
+            <a:pPr marL="0" indent="0">
               <a:buNone/>
             </a:pPr>
             <a:r>
@@ -6159,7 +5929,7 @@
           <a:bodyPr wrap="square" lIns="0" tIns="0" rIns="0" bIns="0" rtlCol="0" anchor="ctr"/>
           <a:lstStyle/>
           <a:p>
-            <a:pPr indent="0" marL="0">
+            <a:pPr marL="0" indent="0">
               <a:buNone/>
             </a:pPr>
             <a:r>
@@ -6198,7 +5968,7 @@
           <a:bodyPr wrap="square" lIns="0" tIns="0" rIns="0" bIns="0" rtlCol="0" anchor="t"/>
           <a:lstStyle/>
           <a:p>
-            <a:pPr indent="0" marL="0">
+            <a:pPr marL="0" indent="0">
               <a:buNone/>
             </a:pPr>
             <a:r>
@@ -6234,7 +6004,7 @@
           <a:bodyPr wrap="square" lIns="0" tIns="0" rIns="0" bIns="0" rtlCol="0" anchor="ctr"/>
           <a:lstStyle/>
           <a:p>
-            <a:pPr indent="0" marL="0">
+            <a:pPr marL="0" indent="0">
               <a:buNone/>
             </a:pPr>
             <a:r>
@@ -6273,7 +6043,7 @@
           <a:bodyPr wrap="square" lIns="0" tIns="0" rIns="0" bIns="0" rtlCol="0" anchor="t"/>
           <a:lstStyle/>
           <a:p>
-            <a:pPr indent="0" marL="0">
+            <a:pPr marL="0" indent="0">
               <a:buNone/>
             </a:pPr>
             <a:r>
@@ -6309,7 +6079,7 @@
           <a:bodyPr wrap="square" lIns="0" tIns="0" rIns="0" bIns="0" rtlCol="0" anchor="t"/>
           <a:lstStyle/>
           <a:p>
-            <a:pPr indent="0" marL="0">
+            <a:pPr marL="0" indent="0">
               <a:buNone/>
             </a:pPr>
             <a:r>
@@ -6350,7 +6120,7 @@
             <a:prstDash val="solid"/>
           </a:ln>
           <a:effectLst>
-            <a:outerShdw sx="100000" sy="100000" kx="0" ky="0" algn="bl" rotWithShape="0" blurRad="76200" dist="25400" dir="5400000">
+            <a:outerShdw blurRad="76200" dist="25400" dir="5400000" algn="bl" rotWithShape="0">
               <a:srgbClr val="000000">
                 <a:alpha val="18000"/>
               </a:srgbClr>
@@ -6360,14 +6130,14 @@
       </p:sp>
       <p:pic>
         <p:nvPicPr>
-          <p:cNvPr id="13" name="EKS cluster active in the AWS Console" descr="EKS cluster active in the AWS Console">    </p:cNvPr>
+          <p:cNvPr id="13" name="EKS cluster active in the AWS Console" descr="EKS cluster active in the AWS Console"/>
           <p:cNvPicPr>
             <a:picLocks noChangeAspect="1"/>
           </p:cNvPicPr>
           <p:nvPr/>
         </p:nvPicPr>
         <p:blipFill>
-          <a:blip r:embed="rId1"/>
+          <a:blip r:embed="rId3"/>
           <a:stretch>
             <a:fillRect/>
           </a:stretch>
@@ -6403,7 +6173,7 @@
           <a:bodyPr wrap="square" lIns="0" tIns="0" rIns="0" bIns="0" rtlCol="0" anchor="ctr"/>
           <a:lstStyle/>
           <a:p>
-            <a:pPr indent="0" marL="0">
+            <a:pPr marL="0" indent="0">
               <a:buNone/>
             </a:pPr>
             <a:r>
@@ -6438,7 +6208,7 @@
           </a:prstGeom>
           <a:extLst>
             <a:ext uri="{C572A759-6A51-4108-AA02-DFA0A04FC94B}">
-              <ma14:wrappingTextBoxFlag xmlns:ma14="http://schemas.microsoft.com/office/mac/drawingml/2011/main" val="0"/>
+              <ma14:wrappingTextBoxFlag xmlns:ma14="http://schemas.microsoft.com/office/mac/drawingml/2011/main" xmlns="" val="0"/>
             </a:ext>
           </a:extLst>
         </p:spPr>
@@ -6456,7 +6226,7 @@
           <a:p>
             <a:pPr algn="r"/>
             <a:fld id="{F7021451-1387-4CA6-816F-3879F97B5CBC}" type="slidenum">
-              <a:rPr b="0" lang="en-US"/>
+              <a:rPr lang="en-US" b="0"/>
               <a:t>6</a:t>
             </a:fld>
             <a:endParaRPr lang="en-US"/>
@@ -6491,9 +6261,11 @@
       <p:sp>
         <p:nvSpPr>
           <p:cNvPr id="2" name="Text 0"/>
-          <p:cNvSpPr/>
+          <p:cNvSpPr>
+            <a:spLocks noGrp="1"/>
+          </p:cNvSpPr>
           <p:nvPr>
-            <p:ph idx="100" type="title" hasCustomPrompt="1"/>
+            <p:ph type="title" idx="100" hasCustomPrompt="1"/>
           </p:nvPr>
         </p:nvSpPr>
         <p:spPr>
@@ -6511,7 +6283,7 @@
           <a:bodyPr wrap="square" lIns="0" tIns="0" rIns="0" bIns="0" rtlCol="0" anchor="ctr"/>
           <a:lstStyle/>
           <a:p>
-            <a:pPr algn="l" indent="0" marL="0">
+            <a:pPr marL="0" indent="0" algn="l">
               <a:buNone/>
             </a:pPr>
             <a:r>
@@ -6575,7 +6347,7 @@
           <a:bodyPr wrap="square" lIns="0" tIns="0" rIns="0" bIns="0" rtlCol="0" anchor="ctr"/>
           <a:lstStyle/>
           <a:p>
-            <a:pPr algn="ctr" indent="0" marL="0">
+            <a:pPr marL="0" indent="0" algn="ctr">
               <a:buNone/>
             </a:pPr>
             <a:r>
@@ -6611,7 +6383,7 @@
           <a:bodyPr wrap="square" lIns="0" tIns="0" rIns="0" bIns="0" rtlCol="0" anchor="t"/>
           <a:lstStyle/>
           <a:p>
-            <a:pPr indent="0" marL="0">
+            <a:pPr marL="0" indent="0">
               <a:buNone/>
             </a:pPr>
             <a:r>
@@ -6625,7 +6397,7 @@
             <a:endParaRPr lang="en-US" sz="1500" dirty="0"/>
           </a:p>
           <a:p>
-            <a:pPr indent="0" marL="0">
+            <a:pPr marL="0" indent="0">
               <a:buNone/>
             </a:pPr>
             <a:r>
@@ -6686,7 +6458,7 @@
           <a:bodyPr wrap="square" lIns="0" tIns="0" rIns="0" bIns="0" rtlCol="0" anchor="ctr"/>
           <a:lstStyle/>
           <a:p>
-            <a:pPr algn="ctr" indent="0" marL="0">
+            <a:pPr marL="0" indent="0" algn="ctr">
               <a:buNone/>
             </a:pPr>
             <a:r>
@@ -6722,7 +6494,7 @@
           <a:bodyPr wrap="square" lIns="0" tIns="0" rIns="0" bIns="0" rtlCol="0" anchor="t"/>
           <a:lstStyle/>
           <a:p>
-            <a:pPr indent="0" marL="0">
+            <a:pPr marL="0" indent="0">
               <a:buNone/>
             </a:pPr>
             <a:r>
@@ -6736,7 +6508,7 @@
             <a:endParaRPr lang="en-US" sz="1500" dirty="0"/>
           </a:p>
           <a:p>
-            <a:pPr indent="0" marL="0">
+            <a:pPr marL="0" indent="0">
               <a:buNone/>
             </a:pPr>
             <a:r>
@@ -6797,7 +6569,7 @@
           <a:bodyPr wrap="square" lIns="0" tIns="0" rIns="0" bIns="0" rtlCol="0" anchor="ctr"/>
           <a:lstStyle/>
           <a:p>
-            <a:pPr algn="ctr" indent="0" marL="0">
+            <a:pPr marL="0" indent="0" algn="ctr">
               <a:buNone/>
             </a:pPr>
             <a:r>
@@ -6833,7 +6605,7 @@
           <a:bodyPr wrap="square" lIns="0" tIns="0" rIns="0" bIns="0" rtlCol="0" anchor="t"/>
           <a:lstStyle/>
           <a:p>
-            <a:pPr indent="0" marL="0">
+            <a:pPr marL="0" indent="0">
               <a:buNone/>
             </a:pPr>
             <a:r>
@@ -6847,7 +6619,7 @@
             <a:endParaRPr lang="en-US" sz="1500" dirty="0"/>
           </a:p>
           <a:p>
-            <a:pPr indent="0" marL="0">
+            <a:pPr marL="0" indent="0">
               <a:buNone/>
             </a:pPr>
             <a:r>
@@ -6908,7 +6680,7 @@
           <a:bodyPr wrap="square" lIns="0" tIns="0" rIns="0" bIns="0" rtlCol="0" anchor="ctr"/>
           <a:lstStyle/>
           <a:p>
-            <a:pPr algn="ctr" indent="0" marL="0">
+            <a:pPr marL="0" indent="0" algn="ctr">
               <a:buNone/>
             </a:pPr>
             <a:r>
@@ -6944,7 +6716,7 @@
           <a:bodyPr wrap="square" lIns="0" tIns="0" rIns="0" bIns="0" rtlCol="0" anchor="t"/>
           <a:lstStyle/>
           <a:p>
-            <a:pPr indent="0" marL="0">
+            <a:pPr marL="0" indent="0">
               <a:buNone/>
             </a:pPr>
             <a:r>
@@ -6958,7 +6730,7 @@
             <a:endParaRPr lang="en-US" sz="1500" dirty="0"/>
           </a:p>
           <a:p>
-            <a:pPr indent="0" marL="0">
+            <a:pPr marL="0" indent="0">
               <a:buNone/>
             </a:pPr>
             <a:r>
@@ -6999,7 +6771,7 @@
             <a:prstDash val="solid"/>
           </a:ln>
           <a:effectLst>
-            <a:outerShdw sx="100000" sy="100000" kx="0" ky="0" algn="bl" rotWithShape="0" blurRad="76200" dist="25400" dir="5400000">
+            <a:outerShdw blurRad="76200" dist="25400" dir="5400000" algn="bl" rotWithShape="0">
               <a:srgbClr val="000000">
                 <a:alpha val="18000"/>
               </a:srgbClr>
@@ -7009,14 +6781,14 @@
       </p:sp>
       <p:pic>
         <p:nvPicPr>
-          <p:cNvPr id="16" name="HPA scaled the backend to 6 replicas" descr="HPA scaled the backend to 6 replicas">    </p:cNvPr>
+          <p:cNvPr id="16" name="HPA scaled the backend to 6 replicas" descr="HPA scaled the backend to 6 replicas"/>
           <p:cNvPicPr>
             <a:picLocks noChangeAspect="1"/>
           </p:cNvPicPr>
           <p:nvPr/>
         </p:nvPicPr>
         <p:blipFill>
-          <a:blip r:embed="rId1"/>
+          <a:blip r:embed="rId3"/>
           <a:stretch>
             <a:fillRect/>
           </a:stretch>
@@ -7052,7 +6824,7 @@
           <a:bodyPr wrap="square" lIns="0" tIns="0" rIns="0" bIns="0" rtlCol="0" anchor="ctr"/>
           <a:lstStyle/>
           <a:p>
-            <a:pPr indent="0" marL="0">
+            <a:pPr marL="0" indent="0">
               <a:buNone/>
             </a:pPr>
             <a:r>
@@ -7087,7 +6859,7 @@
           </a:prstGeom>
           <a:extLst>
             <a:ext uri="{C572A759-6A51-4108-AA02-DFA0A04FC94B}">
-              <ma14:wrappingTextBoxFlag xmlns:ma14="http://schemas.microsoft.com/office/mac/drawingml/2011/main" val="0"/>
+              <ma14:wrappingTextBoxFlag xmlns:ma14="http://schemas.microsoft.com/office/mac/drawingml/2011/main" xmlns="" val="0"/>
             </a:ext>
           </a:extLst>
         </p:spPr>
@@ -7105,7 +6877,7 @@
           <a:p>
             <a:pPr algn="r"/>
             <a:fld id="{F7021451-1387-4CA6-816F-3879F97B5CBC}" type="slidenum">
-              <a:rPr b="0" lang="en-US"/>
+              <a:rPr lang="en-US" b="0"/>
               <a:t>7</a:t>
             </a:fld>
             <a:endParaRPr lang="en-US"/>
@@ -7140,9 +6912,11 @@
       <p:sp>
         <p:nvSpPr>
           <p:cNvPr id="2" name="Text 0"/>
-          <p:cNvSpPr/>
+          <p:cNvSpPr>
+            <a:spLocks noGrp="1"/>
+          </p:cNvSpPr>
           <p:nvPr>
-            <p:ph idx="100" type="title" hasCustomPrompt="1"/>
+            <p:ph type="title" idx="100" hasCustomPrompt="1"/>
           </p:nvPr>
         </p:nvSpPr>
         <p:spPr>
@@ -7160,7 +6934,7 @@
           <a:bodyPr wrap="square" lIns="0" tIns="0" rIns="0" bIns="0" rtlCol="0" anchor="ctr"/>
           <a:lstStyle/>
           <a:p>
-            <a:pPr algn="l" indent="0" marL="0">
+            <a:pPr marL="0" indent="0" algn="l">
               <a:buNone/>
             </a:pPr>
             <a:r>
@@ -7224,7 +6998,7 @@
           <a:bodyPr wrap="square" lIns="0" tIns="0" rIns="0" bIns="0" rtlCol="0" anchor="ctr"/>
           <a:lstStyle/>
           <a:p>
-            <a:pPr algn="ctr" indent="0" marL="0">
+            <a:pPr marL="0" indent="0" algn="ctr">
               <a:buNone/>
             </a:pPr>
             <a:r>
@@ -7260,7 +7034,7 @@
           <a:bodyPr wrap="square" lIns="0" tIns="0" rIns="0" bIns="0" rtlCol="0" anchor="t"/>
           <a:lstStyle/>
           <a:p>
-            <a:pPr indent="0" marL="0">
+            <a:pPr marL="0" indent="0">
               <a:buNone/>
             </a:pPr>
             <a:r>
@@ -7274,7 +7048,7 @@
             <a:endParaRPr lang="en-US" sz="1500" dirty="0"/>
           </a:p>
           <a:p>
-            <a:pPr indent="0" marL="0">
+            <a:pPr marL="0" indent="0">
               <a:buNone/>
             </a:pPr>
             <a:r>
@@ -7335,7 +7109,7 @@
           <a:bodyPr wrap="square" lIns="0" tIns="0" rIns="0" bIns="0" rtlCol="0" anchor="ctr"/>
           <a:lstStyle/>
           <a:p>
-            <a:pPr algn="ctr" indent="0" marL="0">
+            <a:pPr marL="0" indent="0" algn="ctr">
               <a:buNone/>
             </a:pPr>
             <a:r>
@@ -7371,7 +7145,7 @@
           <a:bodyPr wrap="square" lIns="0" tIns="0" rIns="0" bIns="0" rtlCol="0" anchor="t"/>
           <a:lstStyle/>
           <a:p>
-            <a:pPr indent="0" marL="0">
+            <a:pPr marL="0" indent="0">
               <a:buNone/>
             </a:pPr>
             <a:r>
@@ -7385,7 +7159,7 @@
             <a:endParaRPr lang="en-US" sz="1500" dirty="0"/>
           </a:p>
           <a:p>
-            <a:pPr indent="0" marL="0">
+            <a:pPr marL="0" indent="0">
               <a:buNone/>
             </a:pPr>
             <a:r>
@@ -7446,7 +7220,7 @@
           <a:bodyPr wrap="square" lIns="0" tIns="0" rIns="0" bIns="0" rtlCol="0" anchor="ctr"/>
           <a:lstStyle/>
           <a:p>
-            <a:pPr algn="ctr" indent="0" marL="0">
+            <a:pPr marL="0" indent="0" algn="ctr">
               <a:buNone/>
             </a:pPr>
             <a:r>
@@ -7482,7 +7256,7 @@
           <a:bodyPr wrap="square" lIns="0" tIns="0" rIns="0" bIns="0" rtlCol="0" anchor="t"/>
           <a:lstStyle/>
           <a:p>
-            <a:pPr indent="0" marL="0">
+            <a:pPr marL="0" indent="0">
               <a:buNone/>
             </a:pPr>
             <a:r>
@@ -7496,7 +7270,7 @@
             <a:endParaRPr lang="en-US" sz="1500" dirty="0"/>
           </a:p>
           <a:p>
-            <a:pPr indent="0" marL="0">
+            <a:pPr marL="0" indent="0">
               <a:buNone/>
             </a:pPr>
             <a:r>
@@ -7532,7 +7306,7 @@
           <a:bodyPr wrap="square" lIns="0" tIns="0" rIns="0" bIns="0" rtlCol="0" anchor="t"/>
           <a:lstStyle/>
           <a:p>
-            <a:pPr indent="0" marL="0">
+            <a:pPr marL="0" indent="0">
               <a:buNone/>
             </a:pPr>
             <a:r>
@@ -7573,7 +7347,7 @@
             <a:prstDash val="solid"/>
           </a:ln>
           <a:effectLst>
-            <a:outerShdw sx="100000" sy="100000" kx="0" ky="0" algn="bl" rotWithShape="0" blurRad="76200" dist="25400" dir="5400000">
+            <a:outerShdw blurRad="76200" dist="25400" dir="5400000" algn="bl" rotWithShape="0">
               <a:srgbClr val="000000">
                 <a:alpha val="18000"/>
               </a:srgbClr>
@@ -7583,14 +7357,14 @@
       </p:sp>
       <p:pic>
         <p:nvPicPr>
-          <p:cNvPr id="14" name="Grafana dashboard with live data" descr="Grafana dashboard with live data">    </p:cNvPr>
+          <p:cNvPr id="14" name="Grafana dashboard with live data" descr="Grafana dashboard with live data"/>
           <p:cNvPicPr>
             <a:picLocks noChangeAspect="1"/>
           </p:cNvPicPr>
           <p:nvPr/>
         </p:nvPicPr>
         <p:blipFill>
-          <a:blip r:embed="rId1"/>
+          <a:blip r:embed="rId3"/>
           <a:stretch>
             <a:fillRect/>
           </a:stretch>
@@ -7625,7 +7399,7 @@
           </a:prstGeom>
           <a:extLst>
             <a:ext uri="{C572A759-6A51-4108-AA02-DFA0A04FC94B}">
-              <ma14:wrappingTextBoxFlag xmlns:ma14="http://schemas.microsoft.com/office/mac/drawingml/2011/main" val="0"/>
+              <ma14:wrappingTextBoxFlag xmlns:ma14="http://schemas.microsoft.com/office/mac/drawingml/2011/main" xmlns="" val="0"/>
             </a:ext>
           </a:extLst>
         </p:spPr>
@@ -7643,7 +7417,7 @@
           <a:p>
             <a:pPr algn="r"/>
             <a:fld id="{F7021451-1387-4CA6-816F-3879F97B5CBC}" type="slidenum">
-              <a:rPr b="0" lang="en-US"/>
+              <a:rPr lang="en-US" b="0"/>
               <a:t>8</a:t>
             </a:fld>
             <a:endParaRPr lang="en-US"/>
@@ -7678,9 +7452,11 @@
       <p:sp>
         <p:nvSpPr>
           <p:cNvPr id="2" name="Text 0"/>
-          <p:cNvSpPr/>
+          <p:cNvSpPr>
+            <a:spLocks noGrp="1"/>
+          </p:cNvSpPr>
           <p:nvPr>
-            <p:ph idx="100" type="title" hasCustomPrompt="1"/>
+            <p:ph type="title" idx="100" hasCustomPrompt="1"/>
           </p:nvPr>
         </p:nvSpPr>
         <p:spPr>
@@ -7698,7 +7474,7 @@
           <a:bodyPr wrap="square" lIns="0" tIns="0" rIns="0" bIns="0" rtlCol="0" anchor="ctr"/>
           <a:lstStyle/>
           <a:p>
-            <a:pPr algn="l" indent="0" marL="0">
+            <a:pPr marL="0" indent="0" algn="l">
               <a:buNone/>
             </a:pPr>
             <a:r>
@@ -7762,7 +7538,7 @@
           <a:bodyPr wrap="square" lIns="0" tIns="0" rIns="0" bIns="0" rtlCol="0" anchor="ctr"/>
           <a:lstStyle/>
           <a:p>
-            <a:pPr algn="ctr" indent="0" marL="0">
+            <a:pPr marL="0" indent="0" algn="ctr">
               <a:buNone/>
             </a:pPr>
             <a:r>
@@ -7798,7 +7574,7 @@
           <a:bodyPr wrap="square" lIns="0" tIns="0" rIns="0" bIns="0" rtlCol="0" anchor="t"/>
           <a:lstStyle/>
           <a:p>
-            <a:pPr indent="0" marL="0">
+            <a:pPr marL="0" indent="0">
               <a:buNone/>
             </a:pPr>
             <a:r>
@@ -7812,7 +7588,7 @@
             <a:endParaRPr lang="en-US" sz="1500" dirty="0"/>
           </a:p>
           <a:p>
-            <a:pPr indent="0" marL="0">
+            <a:pPr marL="0" indent="0">
               <a:buNone/>
             </a:pPr>
             <a:r>
@@ -7873,7 +7649,7 @@
           <a:bodyPr wrap="square" lIns="0" tIns="0" rIns="0" bIns="0" rtlCol="0" anchor="ctr"/>
           <a:lstStyle/>
           <a:p>
-            <a:pPr algn="ctr" indent="0" marL="0">
+            <a:pPr marL="0" indent="0" algn="ctr">
               <a:buNone/>
             </a:pPr>
             <a:r>
@@ -7909,7 +7685,7 @@
           <a:bodyPr wrap="square" lIns="0" tIns="0" rIns="0" bIns="0" rtlCol="0" anchor="t"/>
           <a:lstStyle/>
           <a:p>
-            <a:pPr indent="0" marL="0">
+            <a:pPr marL="0" indent="0">
               <a:buNone/>
             </a:pPr>
             <a:r>
@@ -7923,7 +7699,7 @@
             <a:endParaRPr lang="en-US" sz="1500" dirty="0"/>
           </a:p>
           <a:p>
-            <a:pPr indent="0" marL="0">
+            <a:pPr marL="0" indent="0">
               <a:buNone/>
             </a:pPr>
             <a:r>
@@ -7984,7 +7760,7 @@
           <a:bodyPr wrap="square" lIns="0" tIns="0" rIns="0" bIns="0" rtlCol="0" anchor="ctr"/>
           <a:lstStyle/>
           <a:p>
-            <a:pPr algn="ctr" indent="0" marL="0">
+            <a:pPr marL="0" indent="0" algn="ctr">
               <a:buNone/>
             </a:pPr>
             <a:r>
@@ -8020,7 +7796,7 @@
           <a:bodyPr wrap="square" lIns="0" tIns="0" rIns="0" bIns="0" rtlCol="0" anchor="t"/>
           <a:lstStyle/>
           <a:p>
-            <a:pPr indent="0" marL="0">
+            <a:pPr marL="0" indent="0">
               <a:buNone/>
             </a:pPr>
             <a:r>
@@ -8034,7 +7810,7 @@
             <a:endParaRPr lang="en-US" sz="1500" dirty="0"/>
           </a:p>
           <a:p>
-            <a:pPr indent="0" marL="0">
+            <a:pPr marL="0" indent="0">
               <a:buNone/>
             </a:pPr>
             <a:r>
@@ -8095,7 +7871,7 @@
           <a:bodyPr wrap="square" lIns="0" tIns="0" rIns="0" bIns="0" rtlCol="0" anchor="ctr"/>
           <a:lstStyle/>
           <a:p>
-            <a:pPr algn="ctr" indent="0" marL="0">
+            <a:pPr marL="0" indent="0" algn="ctr">
               <a:buNone/>
             </a:pPr>
             <a:r>
@@ -8131,7 +7907,7 @@
           <a:bodyPr wrap="square" lIns="0" tIns="0" rIns="0" bIns="0" rtlCol="0" anchor="t"/>
           <a:lstStyle/>
           <a:p>
-            <a:pPr indent="0" marL="0">
+            <a:pPr marL="0" indent="0">
               <a:buNone/>
             </a:pPr>
             <a:r>
@@ -8145,7 +7921,7 @@
             <a:endParaRPr lang="en-US" sz="1500" dirty="0"/>
           </a:p>
           <a:p>
-            <a:pPr indent="0" marL="0">
+            <a:pPr marL="0" indent="0">
               <a:buNone/>
             </a:pPr>
             <a:r>
@@ -8186,7 +7962,7 @@
             <a:prstDash val="solid"/>
           </a:ln>
           <a:effectLst>
-            <a:outerShdw sx="100000" sy="100000" kx="0" ky="0" algn="bl" rotWithShape="0" blurRad="76200" dist="25400" dir="5400000">
+            <a:outerShdw blurRad="76200" dist="25400" dir="5400000" algn="bl" rotWithShape="0">
               <a:srgbClr val="000000">
                 <a:alpha val="18000"/>
               </a:srgbClr>
@@ -8196,14 +7972,14 @@
       </p:sp>
       <p:pic>
         <p:nvPicPr>
-          <p:cNvPr id="16" name="Footer showing the deployed build" descr="Footer showing the deployed build">    </p:cNvPr>
+          <p:cNvPr id="16" name="Footer showing the deployed build" descr="Footer showing the deployed build"/>
           <p:cNvPicPr>
             <a:picLocks noChangeAspect="1"/>
           </p:cNvPicPr>
           <p:nvPr/>
         </p:nvPicPr>
         <p:blipFill>
-          <a:blip r:embed="rId1"/>
+          <a:blip r:embed="rId3"/>
           <a:stretch>
             <a:fillRect/>
           </a:stretch>
@@ -8244,7 +8020,7 @@
             <a:prstDash val="solid"/>
           </a:ln>
           <a:effectLst>
-            <a:outerShdw sx="100000" sy="100000" kx="0" ky="0" algn="bl" rotWithShape="0" blurRad="76200" dist="25400" dir="5400000">
+            <a:outerShdw blurRad="76200" dist="25400" dir="5400000" algn="bl" rotWithShape="0">
               <a:srgbClr val="000000">
                 <a:alpha val="18000"/>
               </a:srgbClr>
@@ -8254,14 +8030,14 @@
       </p:sp>
       <p:pic>
         <p:nvPicPr>
-          <p:cNvPr id="18" name="Pipeline deploying to EKS" descr="Pipeline deploying to EKS">    </p:cNvPr>
+          <p:cNvPr id="18" name="Pipeline deploying to EKS" descr="Pipeline deploying to EKS"/>
           <p:cNvPicPr>
             <a:picLocks noChangeAspect="1"/>
           </p:cNvPicPr>
           <p:nvPr/>
         </p:nvPicPr>
         <p:blipFill>
-          <a:blip r:embed="rId2"/>
+          <a:blip r:embed="rId4"/>
           <a:stretch>
             <a:fillRect/>
           </a:stretch>
@@ -8297,7 +8073,7 @@
           <a:bodyPr wrap="square" lIns="0" tIns="0" rIns="0" bIns="0" rtlCol="0" anchor="t"/>
           <a:lstStyle/>
           <a:p>
-            <a:pPr indent="0" marL="0">
+            <a:pPr marL="0" indent="0">
               <a:buNone/>
             </a:pPr>
             <a:r>
@@ -8332,7 +8108,7 @@
           </a:prstGeom>
           <a:extLst>
             <a:ext uri="{C572A759-6A51-4108-AA02-DFA0A04FC94B}">
-              <ma14:wrappingTextBoxFlag xmlns:ma14="http://schemas.microsoft.com/office/mac/drawingml/2011/main" val="0"/>
+              <ma14:wrappingTextBoxFlag xmlns:ma14="http://schemas.microsoft.com/office/mac/drawingml/2011/main" xmlns="" val="0"/>
             </a:ext>
           </a:extLst>
         </p:spPr>
@@ -8350,7 +8126,7 @@
           <a:p>
             <a:pPr algn="r"/>
             <a:fld id="{F7021451-1387-4CA6-816F-3879F97B5CBC}" type="slidenum">
-              <a:rPr b="0" lang="en-US"/>
+              <a:rPr lang="en-US" b="0"/>
               <a:t>9</a:t>
             </a:fld>
             <a:endParaRPr lang="en-US"/>
@@ -8658,4 +8434,299 @@
     </a:ext>
   </a:extLst>
 </a:theme>
+</file>
+
+<file path=ppt/theme/theme2.xml><?xml version="1.0" encoding="utf-8"?>
+<a:theme xmlns:a="http://schemas.openxmlformats.org/drawingml/2006/main" name="Office Theme">
+  <a:themeElements>
+    <a:clrScheme name="Office">
+      <a:dk1>
+        <a:sysClr val="windowText" lastClr="000000"/>
+      </a:dk1>
+      <a:lt1>
+        <a:sysClr val="window" lastClr="FFFFFF"/>
+      </a:lt1>
+      <a:dk2>
+        <a:srgbClr val="44546A"/>
+      </a:dk2>
+      <a:lt2>
+        <a:srgbClr val="E7E6E6"/>
+      </a:lt2>
+      <a:accent1>
+        <a:srgbClr val="4472C4"/>
+      </a:accent1>
+      <a:accent2>
+        <a:srgbClr val="ED7D31"/>
+      </a:accent2>
+      <a:accent3>
+        <a:srgbClr val="A5A5A5"/>
+      </a:accent3>
+      <a:accent4>
+        <a:srgbClr val="FFC000"/>
+      </a:accent4>
+      <a:accent5>
+        <a:srgbClr val="5B9BD5"/>
+      </a:accent5>
+      <a:accent6>
+        <a:srgbClr val="70AD47"/>
+      </a:accent6>
+      <a:hlink>
+        <a:srgbClr val="0563C1"/>
+      </a:hlink>
+      <a:folHlink>
+        <a:srgbClr val="954F72"/>
+      </a:folHlink>
+    </a:clrScheme>
+    <a:fontScheme name="Office">
+      <a:majorFont>
+        <a:latin typeface="Calibri Light" panose="020F0302020204030204"/>
+        <a:ea typeface=""/>
+        <a:cs typeface=""/>
+        <a:font script="Jpan" typeface="游ゴシック Light"/>
+        <a:font script="Hang" typeface="맑은 고딕"/>
+        <a:font script="Hans" typeface="等线 Light"/>
+        <a:font script="Hant" typeface="新細明體"/>
+        <a:font script="Arab" typeface="Times New Roman"/>
+        <a:font script="Hebr" typeface="Times New Roman"/>
+        <a:font script="Thai" typeface="Angsana New"/>
+        <a:font script="Ethi" typeface="Nyala"/>
+        <a:font script="Beng" typeface="Vrinda"/>
+        <a:font script="Gujr" typeface="Shruti"/>
+        <a:font script="Khmr" typeface="MoolBoran"/>
+        <a:font script="Knda" typeface="Tunga"/>
+        <a:font script="Guru" typeface="Raavi"/>
+        <a:font script="Cans" typeface="Euphemia"/>
+        <a:font script="Cher" typeface="Plantagenet Cherokee"/>
+        <a:font script="Yiii" typeface="Microsoft Yi Baiti"/>
+        <a:font script="Tibt" typeface="Microsoft Himalaya"/>
+        <a:font script="Thaa" typeface="MV Boli"/>
+        <a:font script="Deva" typeface="Mangal"/>
+        <a:font script="Telu" typeface="Gautami"/>
+        <a:font script="Taml" typeface="Latha"/>
+        <a:font script="Syrc" typeface="Estrangelo Edessa"/>
+        <a:font script="Orya" typeface="Kalinga"/>
+        <a:font script="Mlym" typeface="Kartika"/>
+        <a:font script="Laoo" typeface="DokChampa"/>
+        <a:font script="Sinh" typeface="Iskoola Pota"/>
+        <a:font script="Mong" typeface="Mongolian Baiti"/>
+        <a:font script="Viet" typeface="Times New Roman"/>
+        <a:font script="Uigh" typeface="Microsoft Uighur"/>
+        <a:font script="Geor" typeface="Sylfaen"/>
+        <a:font script="Armn" typeface="Arial"/>
+        <a:font script="Bugi" typeface="Leelawadee UI"/>
+        <a:font script="Bopo" typeface="Microsoft JhengHei"/>
+        <a:font script="Java" typeface="Javanese Text"/>
+        <a:font script="Lisu" typeface="Segoe UI"/>
+        <a:font script="Mymr" typeface="Myanmar Text"/>
+        <a:font script="Nkoo" typeface="Ebrima"/>
+        <a:font script="Olck" typeface="Nirmala UI"/>
+        <a:font script="Osma" typeface="Ebrima"/>
+        <a:font script="Phag" typeface="Phagspa"/>
+        <a:font script="Syrn" typeface="Estrangelo Edessa"/>
+        <a:font script="Syrj" typeface="Estrangelo Edessa"/>
+        <a:font script="Syre" typeface="Estrangelo Edessa"/>
+        <a:font script="Sora" typeface="Nirmala UI"/>
+        <a:font script="Tale" typeface="Microsoft Tai Le"/>
+        <a:font script="Talu" typeface="Microsoft New Tai Lue"/>
+        <a:font script="Tfng" typeface="Ebrima"/>
+      </a:majorFont>
+      <a:minorFont>
+        <a:latin typeface="Calibri" panose="020F0502020204030204"/>
+        <a:ea typeface=""/>
+        <a:cs typeface=""/>
+        <a:font script="Jpan" typeface="游ゴシック"/>
+        <a:font script="Hang" typeface="맑은 고딕"/>
+        <a:font script="Hans" typeface="等线"/>
+        <a:font script="Hant" typeface="新細明體"/>
+        <a:font script="Arab" typeface="Arial"/>
+        <a:font script="Hebr" typeface="Arial"/>
+        <a:font script="Thai" typeface="Cordia New"/>
+        <a:font script="Ethi" typeface="Nyala"/>
+        <a:font script="Beng" typeface="Vrinda"/>
+        <a:font script="Gujr" typeface="Shruti"/>
+        <a:font script="Khmr" typeface="DaunPenh"/>
+        <a:font script="Knda" typeface="Tunga"/>
+        <a:font script="Guru" typeface="Raavi"/>
+        <a:font script="Cans" typeface="Euphemia"/>
+        <a:font script="Cher" typeface="Plantagenet Cherokee"/>
+        <a:font script="Yiii" typeface="Microsoft Yi Baiti"/>
+        <a:font script="Tibt" typeface="Microsoft Himalaya"/>
+        <a:font script="Thaa" typeface="MV Boli"/>
+        <a:font script="Deva" typeface="Mangal"/>
+        <a:font script="Telu" typeface="Gautami"/>
+        <a:font script="Taml" typeface="Latha"/>
+        <a:font script="Syrc" typeface="Estrangelo Edessa"/>
+        <a:font script="Orya" typeface="Kalinga"/>
+        <a:font script="Mlym" typeface="Kartika"/>
+        <a:font script="Laoo" typeface="DokChampa"/>
+        <a:font script="Sinh" typeface="Iskoola Pota"/>
+        <a:font script="Mong" typeface="Mongolian Baiti"/>
+        <a:font script="Viet" typeface="Arial"/>
+        <a:font script="Uigh" typeface="Microsoft Uighur"/>
+        <a:font script="Geor" typeface="Sylfaen"/>
+        <a:font script="Armn" typeface="Arial"/>
+        <a:font script="Bugi" typeface="Leelawadee UI"/>
+        <a:font script="Bopo" typeface="Microsoft JhengHei"/>
+        <a:font script="Java" typeface="Javanese Text"/>
+        <a:font script="Lisu" typeface="Segoe UI"/>
+        <a:font script="Mymr" typeface="Myanmar Text"/>
+        <a:font script="Nkoo" typeface="Ebrima"/>
+        <a:font script="Olck" typeface="Nirmala UI"/>
+        <a:font script="Osma" typeface="Ebrima"/>
+        <a:font script="Phag" typeface="Phagspa"/>
+        <a:font script="Syrn" typeface="Estrangelo Edessa"/>
+        <a:font script="Syrj" typeface="Estrangelo Edessa"/>
+        <a:font script="Syre" typeface="Estrangelo Edessa"/>
+        <a:font script="Sora" typeface="Nirmala UI"/>
+        <a:font script="Tale" typeface="Microsoft Tai Le"/>
+        <a:font script="Talu" typeface="Microsoft New Tai Lue"/>
+        <a:font script="Tfng" typeface="Ebrima"/>
+      </a:minorFont>
+    </a:fontScheme>
+    <a:fmtScheme name="Office">
+      <a:fillStyleLst>
+        <a:solidFill>
+          <a:schemeClr val="phClr"/>
+        </a:solidFill>
+        <a:gradFill rotWithShape="1">
+          <a:gsLst>
+            <a:gs pos="0">
+              <a:schemeClr val="phClr">
+                <a:lumMod val="110000"/>
+                <a:satMod val="105000"/>
+                <a:tint val="67000"/>
+              </a:schemeClr>
+            </a:gs>
+            <a:gs pos="50000">
+              <a:schemeClr val="phClr">
+                <a:lumMod val="105000"/>
+                <a:satMod val="103000"/>
+                <a:tint val="73000"/>
+              </a:schemeClr>
+            </a:gs>
+            <a:gs pos="100000">
+              <a:schemeClr val="phClr">
+                <a:lumMod val="105000"/>
+                <a:satMod val="109000"/>
+                <a:tint val="81000"/>
+              </a:schemeClr>
+            </a:gs>
+          </a:gsLst>
+          <a:lin ang="5400000" scaled="0"/>
+        </a:gradFill>
+        <a:gradFill rotWithShape="1">
+          <a:gsLst>
+            <a:gs pos="0">
+              <a:schemeClr val="phClr">
+                <a:satMod val="103000"/>
+                <a:lumMod val="102000"/>
+                <a:tint val="94000"/>
+              </a:schemeClr>
+            </a:gs>
+            <a:gs pos="50000">
+              <a:schemeClr val="phClr">
+                <a:satMod val="110000"/>
+                <a:lumMod val="100000"/>
+                <a:shade val="100000"/>
+              </a:schemeClr>
+            </a:gs>
+            <a:gs pos="100000">
+              <a:schemeClr val="phClr">
+                <a:lumMod val="99000"/>
+                <a:satMod val="120000"/>
+                <a:shade val="78000"/>
+              </a:schemeClr>
+            </a:gs>
+          </a:gsLst>
+          <a:lin ang="5400000" scaled="0"/>
+        </a:gradFill>
+      </a:fillStyleLst>
+      <a:lnStyleLst>
+        <a:ln w="6350" cap="flat" cmpd="sng" algn="ctr">
+          <a:solidFill>
+            <a:schemeClr val="phClr"/>
+          </a:solidFill>
+          <a:prstDash val="solid"/>
+          <a:miter lim="800000"/>
+        </a:ln>
+        <a:ln w="12700" cap="flat" cmpd="sng" algn="ctr">
+          <a:solidFill>
+            <a:schemeClr val="phClr"/>
+          </a:solidFill>
+          <a:prstDash val="solid"/>
+          <a:miter lim="800000"/>
+        </a:ln>
+        <a:ln w="19050" cap="flat" cmpd="sng" algn="ctr">
+          <a:solidFill>
+            <a:schemeClr val="phClr"/>
+          </a:solidFill>
+          <a:prstDash val="solid"/>
+          <a:miter lim="800000"/>
+        </a:ln>
+      </a:lnStyleLst>
+      <a:effectStyleLst>
+        <a:effectStyle>
+          <a:effectLst/>
+        </a:effectStyle>
+        <a:effectStyle>
+          <a:effectLst/>
+        </a:effectStyle>
+        <a:effectStyle>
+          <a:effectLst>
+            <a:outerShdw blurRad="57150" dist="19050" dir="5400000" algn="ctr" rotWithShape="0">
+              <a:srgbClr val="000000">
+                <a:alpha val="63000"/>
+              </a:srgbClr>
+            </a:outerShdw>
+          </a:effectLst>
+        </a:effectStyle>
+      </a:effectStyleLst>
+      <a:bgFillStyleLst>
+        <a:solidFill>
+          <a:schemeClr val="phClr"/>
+        </a:solidFill>
+        <a:solidFill>
+          <a:schemeClr val="phClr">
+            <a:tint val="95000"/>
+            <a:satMod val="170000"/>
+          </a:schemeClr>
+        </a:solidFill>
+        <a:gradFill rotWithShape="1">
+          <a:gsLst>
+            <a:gs pos="0">
+              <a:schemeClr val="phClr">
+                <a:tint val="93000"/>
+                <a:satMod val="150000"/>
+                <a:shade val="98000"/>
+                <a:lumMod val="102000"/>
+              </a:schemeClr>
+            </a:gs>
+            <a:gs pos="50000">
+              <a:schemeClr val="phClr">
+                <a:tint val="98000"/>
+                <a:satMod val="130000"/>
+                <a:shade val="90000"/>
+                <a:lumMod val="103000"/>
+              </a:schemeClr>
+            </a:gs>
+            <a:gs pos="100000">
+              <a:schemeClr val="phClr">
+                <a:shade val="63000"/>
+                <a:satMod val="120000"/>
+              </a:schemeClr>
+            </a:gs>
+          </a:gsLst>
+          <a:lin ang="5400000" scaled="0"/>
+        </a:gradFill>
+      </a:bgFillStyleLst>
+    </a:fmtScheme>
+  </a:themeElements>
+  <a:objectDefaults/>
+  <a:extraClrSchemeLst/>
+  <a:extLst>
+    <a:ext uri="{05A4C25C-085E-4340-85A3-A5531E510DB2}">
+      <thm15:themeFamily xmlns:thm15="http://schemas.microsoft.com/office/thememl/2012/main" name="Office Theme" id="{62F939B6-93AF-4DB8-9C6B-D6C7DFDC589F}" vid="{4A3C46E8-61CC-4603-A589-7422A47A8E4A}"/>
+    </a:ext>
+  </a:extLst>
+</a:theme>
 </file>
</xml_diff>